<commit_message>
Daily rebuild Sat 05/30/2026  7:59:29.99
</commit_message>
<xml_diff>
--- a/generated/DSG/DSG_May_2026_Snapshot.pptx
+++ b/generated/DSG/DSG_May_2026_Snapshot.pptx
@@ -3367,7 +3367,7 @@
                 </a:solidFill>
                 <a:latin typeface="Calibri"/>
               </a:rPr>
-              <a:t>As of May 29, 2026  |  Confidential</a:t>
+              <a:t>As of May 30, 2026  |  Confidential</a:t>
             </a:r>
           </a:p>
         </p:txBody>
@@ -3646,7 +3646,7 @@
                 </a:solidFill>
                 <a:latin typeface="Calibri"/>
               </a:rPr>
-              <a:t>164 Accounts  |  $5.08M GWP  |  May 29, 2026</a:t>
+              <a:t>166 Accounts  |  $5.14M GWP  |  May 30, 2026</a:t>
             </a:r>
           </a:p>
         </p:txBody>
@@ -3767,7 +3767,7 @@
                 </a:solidFill>
                 <a:latin typeface="Calibri Light"/>
               </a:rPr>
-              <a:t>7,446</a:t>
+              <a:t>7,527</a:t>
             </a:r>
           </a:p>
         </p:txBody>
@@ -3915,7 +3915,7 @@
                 </a:solidFill>
                 <a:latin typeface="Calibri Light"/>
               </a:rPr>
-              <a:t>164</a:t>
+              <a:t>166</a:t>
             </a:r>
           </a:p>
         </p:txBody>
@@ -4063,7 +4063,7 @@
                 </a:solidFill>
                 <a:latin typeface="Calibri Light"/>
               </a:rPr>
-              <a:t>$5.08M</a:t>
+              <a:t>$5.14M</a:t>
             </a:r>
           </a:p>
         </p:txBody>
@@ -4211,7 +4211,7 @@
                 </a:solidFill>
                 <a:latin typeface="Calibri Light"/>
               </a:rPr>
-              <a:t>$30,947</a:t>
+              <a:t>$30,966</a:t>
             </a:r>
           </a:p>
         </p:txBody>
@@ -4507,7 +4507,7 @@
                 </a:solidFill>
                 <a:latin typeface="Calibri Light"/>
               </a:rPr>
-              <a:t>82/541</a:t>
+              <a:t>83/544</a:t>
             </a:r>
           </a:p>
         </p:txBody>
@@ -4577,7 +4577,7 @@
                 </a:solidFill>
                 <a:latin typeface="Calibri"/>
               </a:rPr>
-              <a:t>459 not yet binding</a:t>
+              <a:t>461 not yet binding</a:t>
             </a:r>
           </a:p>
         </p:txBody>
@@ -4612,7 +4612,7 @@
                 </a:solidFill>
                 <a:latin typeface="Calibri"/>
               </a:rPr>
-              <a:t>Concentration: Top agency = 11% of GWP  ·  Top 5 agencies = 31% of GWP  ·  459 agencies submitting but not yet binding</a:t>
+              <a:t>Concentration: Top agency = 11% of GWP  ·  Top 5 agencies = 31% of GWP  ·  461 agencies submitting but not yet binding</a:t>
             </a:r>
           </a:p>
         </p:txBody>
@@ -5890,7 +5890,7 @@
                 </a:solidFill>
                 <a:latin typeface="Calibri Light"/>
               </a:rPr>
-              <a:t>34</a:t>
+              <a:t>36</a:t>
             </a:r>
           </a:p>
         </p:txBody>
@@ -5960,7 +5960,7 @@
                 </a:solidFill>
                 <a:latin typeface="Calibri"/>
               </a:rPr>
-              <a:t>$1,425K GWP</a:t>
+              <a:t>$1,490K GWP</a:t>
             </a:r>
           </a:p>
         </p:txBody>
@@ -5995,7 +5995,7 @@
                 </a:solidFill>
                 <a:latin typeface="Calibri"/>
               </a:rPr>
-              <a:t>1,492 subs · 2.3% bind</a:t>
+              <a:t>1,573 subs · 2.3% bind</a:t>
             </a:r>
           </a:p>
         </p:txBody>
@@ -6073,7 +6073,7 @@
                 </a:solidFill>
                 <a:latin typeface="Calibri"/>
               </a:rPr>
-              <a:t>Source: Metabase Cards 6472 &amp; 10306  ·  May 29, 2026</a:t>
+              <a:t>Source: Metabase Cards 6472 &amp; 10306  ·  May 30, 2026</a:t>
             </a:r>
           </a:p>
         </p:txBody>
@@ -6508,7 +6508,7 @@
                           </a:solidFill>
                           <a:latin typeface="Calibri"/>
                         </a:rPr>
-                        <a:t>11.3%</a:t>
+                        <a:t>11.1%</a:t>
                       </a:r>
                     </a:p>
                   </a:txBody>
@@ -6625,7 +6625,7 @@
                           </a:solidFill>
                           <a:latin typeface="Calibri"/>
                         </a:rPr>
-                        <a:t>6.8%</a:t>
+                        <a:t>6.7%</a:t>
                       </a:r>
                     </a:p>
                   </a:txBody>
@@ -6742,7 +6742,7 @@
                           </a:solidFill>
                           <a:latin typeface="Calibri"/>
                         </a:rPr>
-                        <a:t>5.4%</a:t>
+                        <a:t>5.3%</a:t>
                       </a:r>
                     </a:p>
                   </a:txBody>
@@ -7561,7 +7561,7 @@
                           </a:solidFill>
                           <a:latin typeface="Calibri"/>
                         </a:rPr>
-                        <a:t>2.7%</a:t>
+                        <a:t>2.6%</a:t>
                       </a:r>
                     </a:p>
                   </a:txBody>
@@ -7586,7 +7586,7 @@
                           </a:solidFill>
                           <a:latin typeface="Calibri"/>
                         </a:rPr>
-                        <a:t>Valion Security LLC</a:t>
+                        <a:t>Cal-Valley Insurance Services, Inc.</a:t>
                       </a:r>
                     </a:p>
                   </a:txBody>
@@ -7609,76 +7609,76 @@
                           </a:solidFill>
                           <a:latin typeface="Calibri"/>
                         </a:rPr>
-                        <a:t>Ron Douglas</a:t>
-                      </a:r>
-                    </a:p>
-                  </a:txBody>
-                  <a:tcPr anchor="ctr" marL="73152" marR="73152" marT="27432" marB="27432">
-                    <a:solidFill>
-                      <a:srgbClr val="F5F0FC"/>
-                    </a:solidFill>
-                  </a:tcPr>
-                </a:tc>
-                <a:tc>
-                  <a:txBody>
-                    <a:bodyPr/>
-                    <a:lstStyle/>
-                    <a:p>
-                      <a:pPr algn="ctr"/>
-                      <a:r>
-                        <a:rPr sz="1100" b="0">
-                          <a:solidFill>
-                            <a:srgbClr val="3A3A4A"/>
-                          </a:solidFill>
-                          <a:latin typeface="Calibri"/>
-                        </a:rPr>
-                        <a:t>5</a:t>
-                      </a:r>
-                    </a:p>
-                  </a:txBody>
-                  <a:tcPr anchor="ctr" marL="73152" marR="73152" marT="27432" marB="27432">
-                    <a:solidFill>
-                      <a:srgbClr val="F5F0FC"/>
-                    </a:solidFill>
-                  </a:tcPr>
-                </a:tc>
-                <a:tc>
-                  <a:txBody>
-                    <a:bodyPr/>
-                    <a:lstStyle/>
-                    <a:p>
-                      <a:pPr algn="ctr"/>
-                      <a:r>
-                        <a:rPr sz="1100" b="0">
-                          <a:solidFill>
-                            <a:srgbClr val="3A3A4A"/>
-                          </a:solidFill>
-                          <a:latin typeface="Calibri"/>
-                        </a:rPr>
-                        <a:t>$107,975</a:t>
-                      </a:r>
-                    </a:p>
-                  </a:txBody>
-                  <a:tcPr anchor="ctr" marL="73152" marR="73152" marT="27432" marB="27432">
-                    <a:solidFill>
-                      <a:srgbClr val="F5F0FC"/>
-                    </a:solidFill>
-                  </a:tcPr>
-                </a:tc>
-                <a:tc>
-                  <a:txBody>
-                    <a:bodyPr/>
-                    <a:lstStyle/>
-                    <a:p>
-                      <a:pPr algn="ctr"/>
-                      <a:r>
-                        <a:rPr sz="1100" b="0">
-                          <a:solidFill>
-                            <a:srgbClr val="3A3A4A"/>
-                          </a:solidFill>
-                          <a:latin typeface="Calibri"/>
-                        </a:rPr>
-                        <a:t>2.1%</a:t>
+                        <a:t>Lydia Ramos</a:t>
+                      </a:r>
+                    </a:p>
+                  </a:txBody>
+                  <a:tcPr anchor="ctr" marL="73152" marR="73152" marT="27432" marB="27432">
+                    <a:solidFill>
+                      <a:srgbClr val="F5F0FC"/>
+                    </a:solidFill>
+                  </a:tcPr>
+                </a:tc>
+                <a:tc>
+                  <a:txBody>
+                    <a:bodyPr/>
+                    <a:lstStyle/>
+                    <a:p>
+                      <a:pPr algn="ctr"/>
+                      <a:r>
+                        <a:rPr sz="1100" b="0">
+                          <a:solidFill>
+                            <a:srgbClr val="3A3A4A"/>
+                          </a:solidFill>
+                          <a:latin typeface="Calibri"/>
+                        </a:rPr>
+                        <a:t>2</a:t>
+                      </a:r>
+                    </a:p>
+                  </a:txBody>
+                  <a:tcPr anchor="ctr" marL="73152" marR="73152" marT="27432" marB="27432">
+                    <a:solidFill>
+                      <a:srgbClr val="F5F0FC"/>
+                    </a:solidFill>
+                  </a:tcPr>
+                </a:tc>
+                <a:tc>
+                  <a:txBody>
+                    <a:bodyPr/>
+                    <a:lstStyle/>
+                    <a:p>
+                      <a:pPr algn="ctr"/>
+                      <a:r>
+                        <a:rPr sz="1100" b="0">
+                          <a:solidFill>
+                            <a:srgbClr val="3A3A4A"/>
+                          </a:solidFill>
+                          <a:latin typeface="Calibri"/>
+                        </a:rPr>
+                        <a:t>$123,511</a:t>
+                      </a:r>
+                    </a:p>
+                  </a:txBody>
+                  <a:tcPr anchor="ctr" marL="73152" marR="73152" marT="27432" marB="27432">
+                    <a:solidFill>
+                      <a:srgbClr val="F5F0FC"/>
+                    </a:solidFill>
+                  </a:tcPr>
+                </a:tc>
+                <a:tc>
+                  <a:txBody>
+                    <a:bodyPr/>
+                    <a:lstStyle/>
+                    <a:p>
+                      <a:pPr algn="ctr"/>
+                      <a:r>
+                        <a:rPr sz="1100" b="0">
+                          <a:solidFill>
+                            <a:srgbClr val="3A3A4A"/>
+                          </a:solidFill>
+                          <a:latin typeface="Calibri"/>
+                        </a:rPr>
+                        <a:t>2.4%</a:t>
                       </a:r>
                     </a:p>
                   </a:txBody>
@@ -7703,7 +7703,7 @@
                           </a:solidFill>
                           <a:latin typeface="Calibri"/>
                         </a:rPr>
-                        <a:t>United Advantage Insurance Services</a:t>
+                        <a:t>Valion Security LLC</a:t>
                       </a:r>
                     </a:p>
                   </a:txBody>
@@ -7726,76 +7726,76 @@
                           </a:solidFill>
                           <a:latin typeface="Calibri"/>
                         </a:rPr>
-                        <a:t>Derek Janssen</a:t>
-                      </a:r>
-                    </a:p>
-                  </a:txBody>
-                  <a:tcPr anchor="ctr" marL="73152" marR="73152" marT="27432" marB="27432">
-                    <a:solidFill>
-                      <a:srgbClr val="EDE8F8"/>
-                    </a:solidFill>
-                  </a:tcPr>
-                </a:tc>
-                <a:tc>
-                  <a:txBody>
-                    <a:bodyPr/>
-                    <a:lstStyle/>
-                    <a:p>
-                      <a:pPr algn="ctr"/>
-                      <a:r>
-                        <a:rPr sz="1100" b="0">
-                          <a:solidFill>
-                            <a:srgbClr val="3A3A4A"/>
-                          </a:solidFill>
-                          <a:latin typeface="Calibri"/>
-                        </a:rPr>
-                        <a:t>7</a:t>
-                      </a:r>
-                    </a:p>
-                  </a:txBody>
-                  <a:tcPr anchor="ctr" marL="73152" marR="73152" marT="27432" marB="27432">
-                    <a:solidFill>
-                      <a:srgbClr val="EDE8F8"/>
-                    </a:solidFill>
-                  </a:tcPr>
-                </a:tc>
-                <a:tc>
-                  <a:txBody>
-                    <a:bodyPr/>
-                    <a:lstStyle/>
-                    <a:p>
-                      <a:pPr algn="ctr"/>
-                      <a:r>
-                        <a:rPr sz="1100" b="0">
-                          <a:solidFill>
-                            <a:srgbClr val="3A3A4A"/>
-                          </a:solidFill>
-                          <a:latin typeface="Calibri"/>
-                        </a:rPr>
-                        <a:t>$96,590</a:t>
-                      </a:r>
-                    </a:p>
-                  </a:txBody>
-                  <a:tcPr anchor="ctr" marL="73152" marR="73152" marT="27432" marB="27432">
-                    <a:solidFill>
-                      <a:srgbClr val="EDE8F8"/>
-                    </a:solidFill>
-                  </a:tcPr>
-                </a:tc>
-                <a:tc>
-                  <a:txBody>
-                    <a:bodyPr/>
-                    <a:lstStyle/>
-                    <a:p>
-                      <a:pPr algn="ctr"/>
-                      <a:r>
-                        <a:rPr sz="1100" b="0">
-                          <a:solidFill>
-                            <a:srgbClr val="3A3A4A"/>
-                          </a:solidFill>
-                          <a:latin typeface="Calibri"/>
-                        </a:rPr>
-                        <a:t>1.9%</a:t>
+                        <a:t>Ron Douglas</a:t>
+                      </a:r>
+                    </a:p>
+                  </a:txBody>
+                  <a:tcPr anchor="ctr" marL="73152" marR="73152" marT="27432" marB="27432">
+                    <a:solidFill>
+                      <a:srgbClr val="EDE8F8"/>
+                    </a:solidFill>
+                  </a:tcPr>
+                </a:tc>
+                <a:tc>
+                  <a:txBody>
+                    <a:bodyPr/>
+                    <a:lstStyle/>
+                    <a:p>
+                      <a:pPr algn="ctr"/>
+                      <a:r>
+                        <a:rPr sz="1100" b="0">
+                          <a:solidFill>
+                            <a:srgbClr val="3A3A4A"/>
+                          </a:solidFill>
+                          <a:latin typeface="Calibri"/>
+                        </a:rPr>
+                        <a:t>5</a:t>
+                      </a:r>
+                    </a:p>
+                  </a:txBody>
+                  <a:tcPr anchor="ctr" marL="73152" marR="73152" marT="27432" marB="27432">
+                    <a:solidFill>
+                      <a:srgbClr val="EDE8F8"/>
+                    </a:solidFill>
+                  </a:tcPr>
+                </a:tc>
+                <a:tc>
+                  <a:txBody>
+                    <a:bodyPr/>
+                    <a:lstStyle/>
+                    <a:p>
+                      <a:pPr algn="ctr"/>
+                      <a:r>
+                        <a:rPr sz="1100" b="0">
+                          <a:solidFill>
+                            <a:srgbClr val="3A3A4A"/>
+                          </a:solidFill>
+                          <a:latin typeface="Calibri"/>
+                        </a:rPr>
+                        <a:t>$107,975</a:t>
+                      </a:r>
+                    </a:p>
+                  </a:txBody>
+                  <a:tcPr anchor="ctr" marL="73152" marR="73152" marT="27432" marB="27432">
+                    <a:solidFill>
+                      <a:srgbClr val="EDE8F8"/>
+                    </a:solidFill>
+                  </a:tcPr>
+                </a:tc>
+                <a:tc>
+                  <a:txBody>
+                    <a:bodyPr/>
+                    <a:lstStyle/>
+                    <a:p>
+                      <a:pPr algn="ctr"/>
+                      <a:r>
+                        <a:rPr sz="1100" b="0">
+                          <a:solidFill>
+                            <a:srgbClr val="3A3A4A"/>
+                          </a:solidFill>
+                          <a:latin typeface="Calibri"/>
+                        </a:rPr>
+                        <a:t>2.1%</a:t>
                       </a:r>
                     </a:p>
                   </a:txBody>
@@ -7820,7 +7820,7 @@
                           </a:solidFill>
                           <a:latin typeface="Calibri"/>
                         </a:rPr>
-                        <a:t>Ins Professionals Of Georgia</a:t>
+                        <a:t>United Advantage Insurance Services</a:t>
                       </a:r>
                     </a:p>
                   </a:txBody>
@@ -7843,76 +7843,76 @@
                           </a:solidFill>
                           <a:latin typeface="Calibri"/>
                         </a:rPr>
-                        <a:t>Portia Lewis</a:t>
-                      </a:r>
-                    </a:p>
-                  </a:txBody>
-                  <a:tcPr anchor="ctr" marL="73152" marR="73152" marT="27432" marB="27432">
-                    <a:solidFill>
-                      <a:srgbClr val="F5F0FC"/>
-                    </a:solidFill>
-                  </a:tcPr>
-                </a:tc>
-                <a:tc>
-                  <a:txBody>
-                    <a:bodyPr/>
-                    <a:lstStyle/>
-                    <a:p>
-                      <a:pPr algn="ctr"/>
-                      <a:r>
-                        <a:rPr sz="1100" b="0">
-                          <a:solidFill>
-                            <a:srgbClr val="3A3A4A"/>
-                          </a:solidFill>
-                          <a:latin typeface="Calibri"/>
-                        </a:rPr>
-                        <a:t>3</a:t>
-                      </a:r>
-                    </a:p>
-                  </a:txBody>
-                  <a:tcPr anchor="ctr" marL="73152" marR="73152" marT="27432" marB="27432">
-                    <a:solidFill>
-                      <a:srgbClr val="F5F0FC"/>
-                    </a:solidFill>
-                  </a:tcPr>
-                </a:tc>
-                <a:tc>
-                  <a:txBody>
-                    <a:bodyPr/>
-                    <a:lstStyle/>
-                    <a:p>
-                      <a:pPr algn="ctr"/>
-                      <a:r>
-                        <a:rPr sz="1100" b="0">
-                          <a:solidFill>
-                            <a:srgbClr val="3A3A4A"/>
-                          </a:solidFill>
-                          <a:latin typeface="Calibri"/>
-                        </a:rPr>
-                        <a:t>$91,546</a:t>
-                      </a:r>
-                    </a:p>
-                  </a:txBody>
-                  <a:tcPr anchor="ctr" marL="73152" marR="73152" marT="27432" marB="27432">
-                    <a:solidFill>
-                      <a:srgbClr val="F5F0FC"/>
-                    </a:solidFill>
-                  </a:tcPr>
-                </a:tc>
-                <a:tc>
-                  <a:txBody>
-                    <a:bodyPr/>
-                    <a:lstStyle/>
-                    <a:p>
-                      <a:pPr algn="ctr"/>
-                      <a:r>
-                        <a:rPr sz="1100" b="0">
-                          <a:solidFill>
-                            <a:srgbClr val="3A3A4A"/>
-                          </a:solidFill>
-                          <a:latin typeface="Calibri"/>
-                        </a:rPr>
-                        <a:t>1.8%</a:t>
+                        <a:t>Derek Janssen</a:t>
+                      </a:r>
+                    </a:p>
+                  </a:txBody>
+                  <a:tcPr anchor="ctr" marL="73152" marR="73152" marT="27432" marB="27432">
+                    <a:solidFill>
+                      <a:srgbClr val="F5F0FC"/>
+                    </a:solidFill>
+                  </a:tcPr>
+                </a:tc>
+                <a:tc>
+                  <a:txBody>
+                    <a:bodyPr/>
+                    <a:lstStyle/>
+                    <a:p>
+                      <a:pPr algn="ctr"/>
+                      <a:r>
+                        <a:rPr sz="1100" b="0">
+                          <a:solidFill>
+                            <a:srgbClr val="3A3A4A"/>
+                          </a:solidFill>
+                          <a:latin typeface="Calibri"/>
+                        </a:rPr>
+                        <a:t>7</a:t>
+                      </a:r>
+                    </a:p>
+                  </a:txBody>
+                  <a:tcPr anchor="ctr" marL="73152" marR="73152" marT="27432" marB="27432">
+                    <a:solidFill>
+                      <a:srgbClr val="F5F0FC"/>
+                    </a:solidFill>
+                  </a:tcPr>
+                </a:tc>
+                <a:tc>
+                  <a:txBody>
+                    <a:bodyPr/>
+                    <a:lstStyle/>
+                    <a:p>
+                      <a:pPr algn="ctr"/>
+                      <a:r>
+                        <a:rPr sz="1100" b="0">
+                          <a:solidFill>
+                            <a:srgbClr val="3A3A4A"/>
+                          </a:solidFill>
+                          <a:latin typeface="Calibri"/>
+                        </a:rPr>
+                        <a:t>$96,590</a:t>
+                      </a:r>
+                    </a:p>
+                  </a:txBody>
+                  <a:tcPr anchor="ctr" marL="73152" marR="73152" marT="27432" marB="27432">
+                    <a:solidFill>
+                      <a:srgbClr val="F5F0FC"/>
+                    </a:solidFill>
+                  </a:tcPr>
+                </a:tc>
+                <a:tc>
+                  <a:txBody>
+                    <a:bodyPr/>
+                    <a:lstStyle/>
+                    <a:p>
+                      <a:pPr algn="ctr"/>
+                      <a:r>
+                        <a:rPr sz="1100" b="0">
+                          <a:solidFill>
+                            <a:srgbClr val="3A3A4A"/>
+                          </a:solidFill>
+                          <a:latin typeface="Calibri"/>
+                        </a:rPr>
+                        <a:t>1.9%</a:t>
                       </a:r>
                     </a:p>
                   </a:txBody>
@@ -7937,7 +7937,7 @@
                           </a:solidFill>
                           <a:latin typeface="Calibri"/>
                         </a:rPr>
-                        <a:t>Mohsen Ins. LLC</a:t>
+                        <a:t>Ins Professionals Of Georgia</a:t>
                       </a:r>
                     </a:p>
                   </a:txBody>
@@ -7960,76 +7960,76 @@
                           </a:solidFill>
                           <a:latin typeface="Calibri"/>
                         </a:rPr>
-                        <a:t>Derek Janssen</a:t>
-                      </a:r>
-                    </a:p>
-                  </a:txBody>
-                  <a:tcPr anchor="ctr" marL="73152" marR="73152" marT="27432" marB="27432">
-                    <a:solidFill>
-                      <a:srgbClr val="EDE8F8"/>
-                    </a:solidFill>
-                  </a:tcPr>
-                </a:tc>
-                <a:tc>
-                  <a:txBody>
-                    <a:bodyPr/>
-                    <a:lstStyle/>
-                    <a:p>
-                      <a:pPr algn="ctr"/>
-                      <a:r>
-                        <a:rPr sz="1100" b="0">
-                          <a:solidFill>
-                            <a:srgbClr val="3A3A4A"/>
-                          </a:solidFill>
-                          <a:latin typeface="Calibri"/>
-                        </a:rPr>
-                        <a:t>1</a:t>
-                      </a:r>
-                    </a:p>
-                  </a:txBody>
-                  <a:tcPr anchor="ctr" marL="73152" marR="73152" marT="27432" marB="27432">
-                    <a:solidFill>
-                      <a:srgbClr val="EDE8F8"/>
-                    </a:solidFill>
-                  </a:tcPr>
-                </a:tc>
-                <a:tc>
-                  <a:txBody>
-                    <a:bodyPr/>
-                    <a:lstStyle/>
-                    <a:p>
-                      <a:pPr algn="ctr"/>
-                      <a:r>
-                        <a:rPr sz="1100" b="0">
-                          <a:solidFill>
-                            <a:srgbClr val="3A3A4A"/>
-                          </a:solidFill>
-                          <a:latin typeface="Calibri"/>
-                        </a:rPr>
-                        <a:t>$87,610</a:t>
-                      </a:r>
-                    </a:p>
-                  </a:txBody>
-                  <a:tcPr anchor="ctr" marL="73152" marR="73152" marT="27432" marB="27432">
-                    <a:solidFill>
-                      <a:srgbClr val="EDE8F8"/>
-                    </a:solidFill>
-                  </a:tcPr>
-                </a:tc>
-                <a:tc>
-                  <a:txBody>
-                    <a:bodyPr/>
-                    <a:lstStyle/>
-                    <a:p>
-                      <a:pPr algn="ctr"/>
-                      <a:r>
-                        <a:rPr sz="1100" b="0">
-                          <a:solidFill>
-                            <a:srgbClr val="3A3A4A"/>
-                          </a:solidFill>
-                          <a:latin typeface="Calibri"/>
-                        </a:rPr>
-                        <a:t>1.7%</a:t>
+                        <a:t>Portia Lewis</a:t>
+                      </a:r>
+                    </a:p>
+                  </a:txBody>
+                  <a:tcPr anchor="ctr" marL="73152" marR="73152" marT="27432" marB="27432">
+                    <a:solidFill>
+                      <a:srgbClr val="EDE8F8"/>
+                    </a:solidFill>
+                  </a:tcPr>
+                </a:tc>
+                <a:tc>
+                  <a:txBody>
+                    <a:bodyPr/>
+                    <a:lstStyle/>
+                    <a:p>
+                      <a:pPr algn="ctr"/>
+                      <a:r>
+                        <a:rPr sz="1100" b="0">
+                          <a:solidFill>
+                            <a:srgbClr val="3A3A4A"/>
+                          </a:solidFill>
+                          <a:latin typeface="Calibri"/>
+                        </a:rPr>
+                        <a:t>3</a:t>
+                      </a:r>
+                    </a:p>
+                  </a:txBody>
+                  <a:tcPr anchor="ctr" marL="73152" marR="73152" marT="27432" marB="27432">
+                    <a:solidFill>
+                      <a:srgbClr val="EDE8F8"/>
+                    </a:solidFill>
+                  </a:tcPr>
+                </a:tc>
+                <a:tc>
+                  <a:txBody>
+                    <a:bodyPr/>
+                    <a:lstStyle/>
+                    <a:p>
+                      <a:pPr algn="ctr"/>
+                      <a:r>
+                        <a:rPr sz="1100" b="0">
+                          <a:solidFill>
+                            <a:srgbClr val="3A3A4A"/>
+                          </a:solidFill>
+                          <a:latin typeface="Calibri"/>
+                        </a:rPr>
+                        <a:t>$91,546</a:t>
+                      </a:r>
+                    </a:p>
+                  </a:txBody>
+                  <a:tcPr anchor="ctr" marL="73152" marR="73152" marT="27432" marB="27432">
+                    <a:solidFill>
+                      <a:srgbClr val="EDE8F8"/>
+                    </a:solidFill>
+                  </a:tcPr>
+                </a:tc>
+                <a:tc>
+                  <a:txBody>
+                    <a:bodyPr/>
+                    <a:lstStyle/>
+                    <a:p>
+                      <a:pPr algn="ctr"/>
+                      <a:r>
+                        <a:rPr sz="1100" b="0">
+                          <a:solidFill>
+                            <a:srgbClr val="3A3A4A"/>
+                          </a:solidFill>
+                          <a:latin typeface="Calibri"/>
+                        </a:rPr>
+                        <a:t>1.8%</a:t>
                       </a:r>
                     </a:p>
                   </a:txBody>
@@ -8054,7 +8054,7 @@
                           </a:solidFill>
                           <a:latin typeface="Calibri"/>
                         </a:rPr>
-                        <a:t>PR Risk Management Group Inc.</a:t>
+                        <a:t>Mohsen Ins. LLC</a:t>
                       </a:r>
                     </a:p>
                   </a:txBody>
@@ -8077,7 +8077,7 @@
                           </a:solidFill>
                           <a:latin typeface="Calibri"/>
                         </a:rPr>
-                        <a:t>—</a:t>
+                        <a:t>Derek Janssen</a:t>
                       </a:r>
                     </a:p>
                   </a:txBody>
@@ -8123,7 +8123,7 @@
                           </a:solidFill>
                           <a:latin typeface="Calibri"/>
                         </a:rPr>
-                        <a:t>$85,813</a:t>
+                        <a:t>$87,610</a:t>
                       </a:r>
                     </a:p>
                   </a:txBody>
@@ -8191,7 +8191,7 @@
                 </a:solidFill>
                 <a:latin typeface="Calibri"/>
               </a:rPr>
-              <a:t>Top 15 agencies = 55% of total GWP  ·  83 producing agencies YTD</a:t>
+              <a:t>Top 15 agencies = 55% of total GWP  ·  84 producing agencies YTD</a:t>
             </a:r>
           </a:p>
         </p:txBody>
@@ -8269,7 +8269,7 @@
                 </a:solidFill>
                 <a:latin typeface="Calibri"/>
               </a:rPr>
-              <a:t>Source: Metabase Card 6472  ·  May 29, 2026</a:t>
+              <a:t>Source: Metabase Card 6472  ·  May 30, 2026</a:t>
             </a:r>
           </a:p>
         </p:txBody>
@@ -8706,99 +8706,99 @@
                           </a:solidFill>
                           <a:latin typeface="Calibri"/>
                         </a:rPr>
-                        <a:t>618</a:t>
-                      </a:r>
-                    </a:p>
-                  </a:txBody>
-                  <a:tcPr anchor="ctr" marL="73152" marR="73152" marT="27432" marB="27432">
-                    <a:solidFill>
-                      <a:srgbClr val="F5F0FC"/>
-                    </a:solidFill>
-                  </a:tcPr>
-                </a:tc>
-                <a:tc>
-                  <a:txBody>
-                    <a:bodyPr/>
-                    <a:lstStyle/>
-                    <a:p>
-                      <a:pPr algn="ctr"/>
-                      <a:r>
-                        <a:rPr sz="1100" b="0">
-                          <a:solidFill>
-                            <a:srgbClr val="3A3A4A"/>
-                          </a:solidFill>
-                          <a:latin typeface="Calibri"/>
-                        </a:rPr>
-                        <a:t>241</a:t>
-                      </a:r>
-                    </a:p>
-                  </a:txBody>
-                  <a:tcPr anchor="ctr" marL="73152" marR="73152" marT="27432" marB="27432">
-                    <a:solidFill>
-                      <a:srgbClr val="F5F0FC"/>
-                    </a:solidFill>
-                  </a:tcPr>
-                </a:tc>
-                <a:tc>
-                  <a:txBody>
-                    <a:bodyPr/>
-                    <a:lstStyle/>
-                    <a:p>
-                      <a:pPr algn="ctr"/>
-                      <a:r>
-                        <a:rPr sz="1100" b="0">
-                          <a:solidFill>
-                            <a:srgbClr val="3A3A4A"/>
-                          </a:solidFill>
-                          <a:latin typeface="Calibri"/>
-                        </a:rPr>
-                        <a:t>23</a:t>
-                      </a:r>
-                    </a:p>
-                  </a:txBody>
-                  <a:tcPr anchor="ctr" marL="73152" marR="73152" marT="27432" marB="27432">
-                    <a:solidFill>
-                      <a:srgbClr val="F5F0FC"/>
-                    </a:solidFill>
-                  </a:tcPr>
-                </a:tc>
-                <a:tc>
-                  <a:txBody>
-                    <a:bodyPr/>
-                    <a:lstStyle/>
-                    <a:p>
-                      <a:pPr algn="ctr"/>
-                      <a:r>
-                        <a:rPr sz="1100" b="0">
-                          <a:solidFill>
-                            <a:srgbClr val="3A3A4A"/>
-                          </a:solidFill>
-                          <a:latin typeface="Calibri"/>
-                        </a:rPr>
-                        <a:t>3.7%</a:t>
-                      </a:r>
-                    </a:p>
-                  </a:txBody>
-                  <a:tcPr anchor="ctr" marL="73152" marR="73152" marT="27432" marB="27432">
-                    <a:solidFill>
-                      <a:srgbClr val="F5F0FC"/>
-                    </a:solidFill>
-                  </a:tcPr>
-                </a:tc>
-                <a:tc>
-                  <a:txBody>
-                    <a:bodyPr/>
-                    <a:lstStyle/>
-                    <a:p>
-                      <a:pPr algn="ctr"/>
-                      <a:r>
-                        <a:rPr sz="1100" b="0">
-                          <a:solidFill>
-                            <a:srgbClr val="3A3A4A"/>
-                          </a:solidFill>
-                          <a:latin typeface="Calibri"/>
-                        </a:rPr>
-                        <a:t>$796,297</a:t>
+                        <a:t>628</a:t>
+                      </a:r>
+                    </a:p>
+                  </a:txBody>
+                  <a:tcPr anchor="ctr" marL="73152" marR="73152" marT="27432" marB="27432">
+                    <a:solidFill>
+                      <a:srgbClr val="F5F0FC"/>
+                    </a:solidFill>
+                  </a:tcPr>
+                </a:tc>
+                <a:tc>
+                  <a:txBody>
+                    <a:bodyPr/>
+                    <a:lstStyle/>
+                    <a:p>
+                      <a:pPr algn="ctr"/>
+                      <a:r>
+                        <a:rPr sz="1100" b="0">
+                          <a:solidFill>
+                            <a:srgbClr val="3A3A4A"/>
+                          </a:solidFill>
+                          <a:latin typeface="Calibri"/>
+                        </a:rPr>
+                        <a:t>246</a:t>
+                      </a:r>
+                    </a:p>
+                  </a:txBody>
+                  <a:tcPr anchor="ctr" marL="73152" marR="73152" marT="27432" marB="27432">
+                    <a:solidFill>
+                      <a:srgbClr val="F5F0FC"/>
+                    </a:solidFill>
+                  </a:tcPr>
+                </a:tc>
+                <a:tc>
+                  <a:txBody>
+                    <a:bodyPr/>
+                    <a:lstStyle/>
+                    <a:p>
+                      <a:pPr algn="ctr"/>
+                      <a:r>
+                        <a:rPr sz="1100" b="0">
+                          <a:solidFill>
+                            <a:srgbClr val="3A3A4A"/>
+                          </a:solidFill>
+                          <a:latin typeface="Calibri"/>
+                        </a:rPr>
+                        <a:t>24</a:t>
+                      </a:r>
+                    </a:p>
+                  </a:txBody>
+                  <a:tcPr anchor="ctr" marL="73152" marR="73152" marT="27432" marB="27432">
+                    <a:solidFill>
+                      <a:srgbClr val="F5F0FC"/>
+                    </a:solidFill>
+                  </a:tcPr>
+                </a:tc>
+                <a:tc>
+                  <a:txBody>
+                    <a:bodyPr/>
+                    <a:lstStyle/>
+                    <a:p>
+                      <a:pPr algn="ctr"/>
+                      <a:r>
+                        <a:rPr sz="1100" b="0">
+                          <a:solidFill>
+                            <a:srgbClr val="3A3A4A"/>
+                          </a:solidFill>
+                          <a:latin typeface="Calibri"/>
+                        </a:rPr>
+                        <a:t>3.8%</a:t>
+                      </a:r>
+                    </a:p>
+                  </a:txBody>
+                  <a:tcPr anchor="ctr" marL="73152" marR="73152" marT="27432" marB="27432">
+                    <a:solidFill>
+                      <a:srgbClr val="F5F0FC"/>
+                    </a:solidFill>
+                  </a:tcPr>
+                </a:tc>
+                <a:tc>
+                  <a:txBody>
+                    <a:bodyPr/>
+                    <a:lstStyle/>
+                    <a:p>
+                      <a:pPr algn="ctr"/>
+                      <a:r>
+                        <a:rPr sz="1100" b="0">
+                          <a:solidFill>
+                            <a:srgbClr val="3A3A4A"/>
+                          </a:solidFill>
+                          <a:latin typeface="Calibri"/>
+                        </a:rPr>
+                        <a:t>$828,685</a:t>
                       </a:r>
                     </a:p>
                   </a:txBody>
@@ -8869,30 +8869,30 @@
                           </a:solidFill>
                           <a:latin typeface="Calibri"/>
                         </a:rPr>
-                        <a:t>322</a:t>
-                      </a:r>
-                    </a:p>
-                  </a:txBody>
-                  <a:tcPr anchor="ctr" marL="73152" marR="73152" marT="27432" marB="27432">
-                    <a:solidFill>
-                      <a:srgbClr val="EDE8F8"/>
-                    </a:solidFill>
-                  </a:tcPr>
-                </a:tc>
-                <a:tc>
-                  <a:txBody>
-                    <a:bodyPr/>
-                    <a:lstStyle/>
-                    <a:p>
-                      <a:pPr algn="ctr"/>
-                      <a:r>
-                        <a:rPr sz="1100" b="0">
-                          <a:solidFill>
-                            <a:srgbClr val="3A3A4A"/>
-                          </a:solidFill>
-                          <a:latin typeface="Calibri"/>
-                        </a:rPr>
-                        <a:t>157</a:t>
+                        <a:t>330</a:t>
+                      </a:r>
+                    </a:p>
+                  </a:txBody>
+                  <a:tcPr anchor="ctr" marL="73152" marR="73152" marT="27432" marB="27432">
+                    <a:solidFill>
+                      <a:srgbClr val="EDE8F8"/>
+                    </a:solidFill>
+                  </a:tcPr>
+                </a:tc>
+                <a:tc>
+                  <a:txBody>
+                    <a:bodyPr/>
+                    <a:lstStyle/>
+                    <a:p>
+                      <a:pPr algn="ctr"/>
+                      <a:r>
+                        <a:rPr sz="1100" b="0">
+                          <a:solidFill>
+                            <a:srgbClr val="3A3A4A"/>
+                          </a:solidFill>
+                          <a:latin typeface="Calibri"/>
+                        </a:rPr>
+                        <a:t>160</a:t>
                       </a:r>
                     </a:p>
                   </a:txBody>
@@ -8938,7 +8938,7 @@
                           </a:solidFill>
                           <a:latin typeface="Calibri"/>
                         </a:rPr>
-                        <a:t>3.7%</a:t>
+                        <a:t>3.6%</a:t>
                       </a:r>
                     </a:p>
                   </a:txBody>
@@ -9032,30 +9032,30 @@
                           </a:solidFill>
                           <a:latin typeface="Calibri"/>
                         </a:rPr>
-                        <a:t>617</a:t>
-                      </a:r>
-                    </a:p>
-                  </a:txBody>
-                  <a:tcPr anchor="ctr" marL="73152" marR="73152" marT="27432" marB="27432">
-                    <a:solidFill>
-                      <a:srgbClr val="F5F0FC"/>
-                    </a:solidFill>
-                  </a:tcPr>
-                </a:tc>
-                <a:tc>
-                  <a:txBody>
-                    <a:bodyPr/>
-                    <a:lstStyle/>
-                    <a:p>
-                      <a:pPr algn="ctr"/>
-                      <a:r>
-                        <a:rPr sz="1100" b="0">
-                          <a:solidFill>
-                            <a:srgbClr val="3A3A4A"/>
-                          </a:solidFill>
-                          <a:latin typeface="Calibri"/>
-                        </a:rPr>
-                        <a:t>251</a:t>
+                        <a:t>623</a:t>
+                      </a:r>
+                    </a:p>
+                  </a:txBody>
+                  <a:tcPr anchor="ctr" marL="73152" marR="73152" marT="27432" marB="27432">
+                    <a:solidFill>
+                      <a:srgbClr val="F5F0FC"/>
+                    </a:solidFill>
+                  </a:tcPr>
+                </a:tc>
+                <a:tc>
+                  <a:txBody>
+                    <a:bodyPr/>
+                    <a:lstStyle/>
+                    <a:p>
+                      <a:pPr algn="ctr"/>
+                      <a:r>
+                        <a:rPr sz="1100" b="0">
+                          <a:solidFill>
+                            <a:srgbClr val="3A3A4A"/>
+                          </a:solidFill>
+                          <a:latin typeface="Calibri"/>
+                        </a:rPr>
+                        <a:t>254</a:t>
                       </a:r>
                     </a:p>
                   </a:txBody>
@@ -9195,30 +9195,30 @@
                           </a:solidFill>
                           <a:latin typeface="Calibri"/>
                         </a:rPr>
-                        <a:t>1041</a:t>
-                      </a:r>
-                    </a:p>
-                  </a:txBody>
-                  <a:tcPr anchor="ctr" marL="73152" marR="73152" marT="27432" marB="27432">
-                    <a:solidFill>
-                      <a:srgbClr val="EDE8F8"/>
-                    </a:solidFill>
-                  </a:tcPr>
-                </a:tc>
-                <a:tc>
-                  <a:txBody>
-                    <a:bodyPr/>
-                    <a:lstStyle/>
-                    <a:p>
-                      <a:pPr algn="ctr"/>
-                      <a:r>
-                        <a:rPr sz="1100" b="0">
-                          <a:solidFill>
-                            <a:srgbClr val="3A3A4A"/>
-                          </a:solidFill>
-                          <a:latin typeface="Calibri"/>
-                        </a:rPr>
-                        <a:t>386</a:t>
+                        <a:t>1051</a:t>
+                      </a:r>
+                    </a:p>
+                  </a:txBody>
+                  <a:tcPr anchor="ctr" marL="73152" marR="73152" marT="27432" marB="27432">
+                    <a:solidFill>
+                      <a:srgbClr val="EDE8F8"/>
+                    </a:solidFill>
+                  </a:tcPr>
+                </a:tc>
+                <a:tc>
+                  <a:txBody>
+                    <a:bodyPr/>
+                    <a:lstStyle/>
+                    <a:p>
+                      <a:pPr algn="ctr"/>
+                      <a:r>
+                        <a:rPr sz="1100" b="0">
+                          <a:solidFill>
+                            <a:srgbClr val="3A3A4A"/>
+                          </a:solidFill>
+                          <a:latin typeface="Calibri"/>
+                        </a:rPr>
+                        <a:t>390</a:t>
                       </a:r>
                     </a:p>
                   </a:txBody>
@@ -9358,30 +9358,30 @@
                           </a:solidFill>
                           <a:latin typeface="Calibri"/>
                         </a:rPr>
-                        <a:t>443</a:t>
-                      </a:r>
-                    </a:p>
-                  </a:txBody>
-                  <a:tcPr anchor="ctr" marL="73152" marR="73152" marT="27432" marB="27432">
-                    <a:solidFill>
-                      <a:srgbClr val="F5F0FC"/>
-                    </a:solidFill>
-                  </a:tcPr>
-                </a:tc>
-                <a:tc>
-                  <a:txBody>
-                    <a:bodyPr/>
-                    <a:lstStyle/>
-                    <a:p>
-                      <a:pPr algn="ctr"/>
-                      <a:r>
-                        <a:rPr sz="1100" b="0">
-                          <a:solidFill>
-                            <a:srgbClr val="3A3A4A"/>
-                          </a:solidFill>
-                          <a:latin typeface="Calibri"/>
-                        </a:rPr>
-                        <a:t>212</a:t>
+                        <a:t>447</a:t>
+                      </a:r>
+                    </a:p>
+                  </a:txBody>
+                  <a:tcPr anchor="ctr" marL="73152" marR="73152" marT="27432" marB="27432">
+                    <a:solidFill>
+                      <a:srgbClr val="F5F0FC"/>
+                    </a:solidFill>
+                  </a:tcPr>
+                </a:tc>
+                <a:tc>
+                  <a:txBody>
+                    <a:bodyPr/>
+                    <a:lstStyle/>
+                    <a:p>
+                      <a:pPr algn="ctr"/>
+                      <a:r>
+                        <a:rPr sz="1100" b="0">
+                          <a:solidFill>
+                            <a:srgbClr val="3A3A4A"/>
+                          </a:solidFill>
+                          <a:latin typeface="Calibri"/>
+                        </a:rPr>
+                        <a:t>215</a:t>
                       </a:r>
                     </a:p>
                   </a:txBody>
@@ -9521,30 +9521,30 @@
                           </a:solidFill>
                           <a:latin typeface="Calibri"/>
                         </a:rPr>
-                        <a:t>330</a:t>
-                      </a:r>
-                    </a:p>
-                  </a:txBody>
-                  <a:tcPr anchor="ctr" marL="73152" marR="73152" marT="27432" marB="27432">
-                    <a:solidFill>
-                      <a:srgbClr val="EDE8F8"/>
-                    </a:solidFill>
-                  </a:tcPr>
-                </a:tc>
-                <a:tc>
-                  <a:txBody>
-                    <a:bodyPr/>
-                    <a:lstStyle/>
-                    <a:p>
-                      <a:pPr algn="ctr"/>
-                      <a:r>
-                        <a:rPr sz="1100" b="0">
-                          <a:solidFill>
-                            <a:srgbClr val="3A3A4A"/>
-                          </a:solidFill>
-                          <a:latin typeface="Calibri"/>
-                        </a:rPr>
-                        <a:t>161</a:t>
+                        <a:t>334</a:t>
+                      </a:r>
+                    </a:p>
+                  </a:txBody>
+                  <a:tcPr anchor="ctr" marL="73152" marR="73152" marT="27432" marB="27432">
+                    <a:solidFill>
+                      <a:srgbClr val="EDE8F8"/>
+                    </a:solidFill>
+                  </a:tcPr>
+                </a:tc>
+                <a:tc>
+                  <a:txBody>
+                    <a:bodyPr/>
+                    <a:lstStyle/>
+                    <a:p>
+                      <a:pPr algn="ctr"/>
+                      <a:r>
+                        <a:rPr sz="1100" b="0">
+                          <a:solidFill>
+                            <a:srgbClr val="3A3A4A"/>
+                          </a:solidFill>
+                          <a:latin typeface="Calibri"/>
+                        </a:rPr>
+                        <a:t>163</a:t>
                       </a:r>
                     </a:p>
                   </a:txBody>
@@ -9661,122 +9661,122 @@
                           </a:solidFill>
                           <a:latin typeface="Calibri"/>
                         </a:rPr>
-                        <a:t>28</a:t>
-                      </a:r>
-                    </a:p>
-                  </a:txBody>
-                  <a:tcPr anchor="ctr" marL="73152" marR="73152" marT="27432" marB="27432">
-                    <a:solidFill>
-                      <a:srgbClr val="F5F0FC"/>
-                    </a:solidFill>
-                  </a:tcPr>
-                </a:tc>
-                <a:tc>
-                  <a:txBody>
-                    <a:bodyPr/>
-                    <a:lstStyle/>
-                    <a:p>
-                      <a:pPr algn="ctr"/>
-                      <a:r>
-                        <a:rPr sz="1100" b="0">
-                          <a:solidFill>
-                            <a:srgbClr val="3A3A4A"/>
-                          </a:solidFill>
-                          <a:latin typeface="Calibri"/>
-                        </a:rPr>
-                        <a:t>414</a:t>
-                      </a:r>
-                    </a:p>
-                  </a:txBody>
-                  <a:tcPr anchor="ctr" marL="73152" marR="73152" marT="27432" marB="27432">
-                    <a:solidFill>
-                      <a:srgbClr val="F5F0FC"/>
-                    </a:solidFill>
-                  </a:tcPr>
-                </a:tc>
-                <a:tc>
-                  <a:txBody>
-                    <a:bodyPr/>
-                    <a:lstStyle/>
-                    <a:p>
-                      <a:pPr algn="ctr"/>
-                      <a:r>
-                        <a:rPr sz="1100" b="0">
-                          <a:solidFill>
-                            <a:srgbClr val="3A3A4A"/>
-                          </a:solidFill>
-                          <a:latin typeface="Calibri"/>
-                        </a:rPr>
-                        <a:t>165</a:t>
-                      </a:r>
-                    </a:p>
-                  </a:txBody>
-                  <a:tcPr anchor="ctr" marL="73152" marR="73152" marT="27432" marB="27432">
-                    <a:solidFill>
-                      <a:srgbClr val="F5F0FC"/>
-                    </a:solidFill>
-                  </a:tcPr>
-                </a:tc>
-                <a:tc>
-                  <a:txBody>
-                    <a:bodyPr/>
-                    <a:lstStyle/>
-                    <a:p>
-                      <a:pPr algn="ctr"/>
-                      <a:r>
-                        <a:rPr sz="1100" b="0">
-                          <a:solidFill>
-                            <a:srgbClr val="3A3A4A"/>
-                          </a:solidFill>
-                          <a:latin typeface="Calibri"/>
-                        </a:rPr>
-                        <a:t>7</a:t>
-                      </a:r>
-                    </a:p>
-                  </a:txBody>
-                  <a:tcPr anchor="ctr" marL="73152" marR="73152" marT="27432" marB="27432">
-                    <a:solidFill>
-                      <a:srgbClr val="F5F0FC"/>
-                    </a:solidFill>
-                  </a:tcPr>
-                </a:tc>
-                <a:tc>
-                  <a:txBody>
-                    <a:bodyPr/>
-                    <a:lstStyle/>
-                    <a:p>
-                      <a:pPr algn="ctr"/>
-                      <a:r>
-                        <a:rPr sz="1100" b="0">
-                          <a:solidFill>
-                            <a:srgbClr val="3A3A4A"/>
-                          </a:solidFill>
-                          <a:latin typeface="Calibri"/>
-                        </a:rPr>
-                        <a:t>1.7%</a:t>
-                      </a:r>
-                    </a:p>
-                  </a:txBody>
-                  <a:tcPr anchor="ctr" marL="73152" marR="73152" marT="27432" marB="27432">
-                    <a:solidFill>
-                      <a:srgbClr val="F5F0FC"/>
-                    </a:solidFill>
-                  </a:tcPr>
-                </a:tc>
-                <a:tc>
-                  <a:txBody>
-                    <a:bodyPr/>
-                    <a:lstStyle/>
-                    <a:p>
-                      <a:pPr algn="ctr"/>
-                      <a:r>
-                        <a:rPr sz="1100" b="0">
-                          <a:solidFill>
-                            <a:srgbClr val="3A3A4A"/>
-                          </a:solidFill>
-                          <a:latin typeface="Calibri"/>
-                        </a:rPr>
-                        <a:t>$169,596</a:t>
+                        <a:t>29</a:t>
+                      </a:r>
+                    </a:p>
+                  </a:txBody>
+                  <a:tcPr anchor="ctr" marL="73152" marR="73152" marT="27432" marB="27432">
+                    <a:solidFill>
+                      <a:srgbClr val="F5F0FC"/>
+                    </a:solidFill>
+                  </a:tcPr>
+                </a:tc>
+                <a:tc>
+                  <a:txBody>
+                    <a:bodyPr/>
+                    <a:lstStyle/>
+                    <a:p>
+                      <a:pPr algn="ctr"/>
+                      <a:r>
+                        <a:rPr sz="1100" b="0">
+                          <a:solidFill>
+                            <a:srgbClr val="3A3A4A"/>
+                          </a:solidFill>
+                          <a:latin typeface="Calibri"/>
+                        </a:rPr>
+                        <a:t>420</a:t>
+                      </a:r>
+                    </a:p>
+                  </a:txBody>
+                  <a:tcPr anchor="ctr" marL="73152" marR="73152" marT="27432" marB="27432">
+                    <a:solidFill>
+                      <a:srgbClr val="F5F0FC"/>
+                    </a:solidFill>
+                  </a:tcPr>
+                </a:tc>
+                <a:tc>
+                  <a:txBody>
+                    <a:bodyPr/>
+                    <a:lstStyle/>
+                    <a:p>
+                      <a:pPr algn="ctr"/>
+                      <a:r>
+                        <a:rPr sz="1100" b="0">
+                          <a:solidFill>
+                            <a:srgbClr val="3A3A4A"/>
+                          </a:solidFill>
+                          <a:latin typeface="Calibri"/>
+                        </a:rPr>
+                        <a:t>169</a:t>
+                      </a:r>
+                    </a:p>
+                  </a:txBody>
+                  <a:tcPr anchor="ctr" marL="73152" marR="73152" marT="27432" marB="27432">
+                    <a:solidFill>
+                      <a:srgbClr val="F5F0FC"/>
+                    </a:solidFill>
+                  </a:tcPr>
+                </a:tc>
+                <a:tc>
+                  <a:txBody>
+                    <a:bodyPr/>
+                    <a:lstStyle/>
+                    <a:p>
+                      <a:pPr algn="ctr"/>
+                      <a:r>
+                        <a:rPr sz="1100" b="0">
+                          <a:solidFill>
+                            <a:srgbClr val="3A3A4A"/>
+                          </a:solidFill>
+                          <a:latin typeface="Calibri"/>
+                        </a:rPr>
+                        <a:t>8</a:t>
+                      </a:r>
+                    </a:p>
+                  </a:txBody>
+                  <a:tcPr anchor="ctr" marL="73152" marR="73152" marT="27432" marB="27432">
+                    <a:solidFill>
+                      <a:srgbClr val="F5F0FC"/>
+                    </a:solidFill>
+                  </a:tcPr>
+                </a:tc>
+                <a:tc>
+                  <a:txBody>
+                    <a:bodyPr/>
+                    <a:lstStyle/>
+                    <a:p>
+                      <a:pPr algn="ctr"/>
+                      <a:r>
+                        <a:rPr sz="1100" b="0">
+                          <a:solidFill>
+                            <a:srgbClr val="3A3A4A"/>
+                          </a:solidFill>
+                          <a:latin typeface="Calibri"/>
+                        </a:rPr>
+                        <a:t>1.9%</a:t>
+                      </a:r>
+                    </a:p>
+                  </a:txBody>
+                  <a:tcPr anchor="ctr" marL="73152" marR="73152" marT="27432" marB="27432">
+                    <a:solidFill>
+                      <a:srgbClr val="F5F0FC"/>
+                    </a:solidFill>
+                  </a:tcPr>
+                </a:tc>
+                <a:tc>
+                  <a:txBody>
+                    <a:bodyPr/>
+                    <a:lstStyle/>
+                    <a:p>
+                      <a:pPr algn="ctr"/>
+                      <a:r>
+                        <a:rPr sz="1100" b="0">
+                          <a:solidFill>
+                            <a:srgbClr val="3A3A4A"/>
+                          </a:solidFill>
+                          <a:latin typeface="Calibri"/>
+                        </a:rPr>
+                        <a:t>$234,557</a:t>
                       </a:r>
                     </a:p>
                   </a:txBody>
@@ -9847,30 +9847,30 @@
                           </a:solidFill>
                           <a:latin typeface="Calibri"/>
                         </a:rPr>
-                        <a:t>158</a:t>
-                      </a:r>
-                    </a:p>
-                  </a:txBody>
-                  <a:tcPr anchor="ctr" marL="73152" marR="73152" marT="27432" marB="27432">
-                    <a:solidFill>
-                      <a:srgbClr val="EDE8F8"/>
-                    </a:solidFill>
-                  </a:tcPr>
-                </a:tc>
-                <a:tc>
-                  <a:txBody>
-                    <a:bodyPr/>
-                    <a:lstStyle/>
-                    <a:p>
-                      <a:pPr algn="ctr"/>
-                      <a:r>
-                        <a:rPr sz="1100" b="0">
-                          <a:solidFill>
-                            <a:srgbClr val="3A3A4A"/>
-                          </a:solidFill>
-                          <a:latin typeface="Calibri"/>
-                        </a:rPr>
-                        <a:t>73</a:t>
+                        <a:t>159</a:t>
+                      </a:r>
+                    </a:p>
+                  </a:txBody>
+                  <a:tcPr anchor="ctr" marL="73152" marR="73152" marT="27432" marB="27432">
+                    <a:solidFill>
+                      <a:srgbClr val="EDE8F8"/>
+                    </a:solidFill>
+                  </a:tcPr>
+                </a:tc>
+                <a:tc>
+                  <a:txBody>
+                    <a:bodyPr/>
+                    <a:lstStyle/>
+                    <a:p>
+                      <a:pPr algn="ctr"/>
+                      <a:r>
+                        <a:rPr sz="1100" b="0">
+                          <a:solidFill>
+                            <a:srgbClr val="3A3A4A"/>
+                          </a:solidFill>
+                          <a:latin typeface="Calibri"/>
+                        </a:rPr>
+                        <a:t>74</a:t>
                       </a:r>
                     </a:p>
                   </a:txBody>
@@ -10033,7 +10033,7 @@
                           </a:solidFill>
                           <a:latin typeface="Calibri"/>
                         </a:rPr>
-                        <a:t>53</a:t>
+                        <a:t>54</a:t>
                       </a:r>
                     </a:p>
                   </a:txBody>
@@ -10173,30 +10173,30 @@
                           </a:solidFill>
                           <a:latin typeface="Calibri"/>
                         </a:rPr>
-                        <a:t>124</a:t>
-                      </a:r>
-                    </a:p>
-                  </a:txBody>
-                  <a:tcPr anchor="ctr" marL="73152" marR="73152" marT="27432" marB="27432">
-                    <a:solidFill>
-                      <a:srgbClr val="EDE8F8"/>
-                    </a:solidFill>
-                  </a:tcPr>
-                </a:tc>
-                <a:tc>
-                  <a:txBody>
-                    <a:bodyPr/>
-                    <a:lstStyle/>
-                    <a:p>
-                      <a:pPr algn="ctr"/>
-                      <a:r>
-                        <a:rPr sz="1100" b="0">
-                          <a:solidFill>
-                            <a:srgbClr val="3A3A4A"/>
-                          </a:solidFill>
-                          <a:latin typeface="Calibri"/>
-                        </a:rPr>
-                        <a:t>51</a:t>
+                        <a:t>127</a:t>
+                      </a:r>
+                    </a:p>
+                  </a:txBody>
+                  <a:tcPr anchor="ctr" marL="73152" marR="73152" marT="27432" marB="27432">
+                    <a:solidFill>
+                      <a:srgbClr val="EDE8F8"/>
+                    </a:solidFill>
+                  </a:tcPr>
+                </a:tc>
+                <a:tc>
+                  <a:txBody>
+                    <a:bodyPr/>
+                    <a:lstStyle/>
+                    <a:p>
+                      <a:pPr algn="ctr"/>
+                      <a:r>
+                        <a:rPr sz="1100" b="0">
+                          <a:solidFill>
+                            <a:srgbClr val="3A3A4A"/>
+                          </a:solidFill>
+                          <a:latin typeface="Calibri"/>
+                        </a:rPr>
+                        <a:t>53</a:t>
                       </a:r>
                     </a:p>
                   </a:txBody>
@@ -10336,30 +10336,30 @@
                           </a:solidFill>
                           <a:latin typeface="Calibri"/>
                         </a:rPr>
-                        <a:t>223</a:t>
-                      </a:r>
-                    </a:p>
-                  </a:txBody>
-                  <a:tcPr anchor="ctr" marL="73152" marR="73152" marT="27432" marB="27432">
-                    <a:solidFill>
-                      <a:srgbClr val="F5F0FC"/>
-                    </a:solidFill>
-                  </a:tcPr>
-                </a:tc>
-                <a:tc>
-                  <a:txBody>
-                    <a:bodyPr/>
-                    <a:lstStyle/>
-                    <a:p>
-                      <a:pPr algn="ctr"/>
-                      <a:r>
-                        <a:rPr sz="1100" b="0">
-                          <a:solidFill>
-                            <a:srgbClr val="3A3A4A"/>
-                          </a:solidFill>
-                          <a:latin typeface="Calibri"/>
-                        </a:rPr>
-                        <a:t>126</a:t>
+                        <a:t>227</a:t>
+                      </a:r>
+                    </a:p>
+                  </a:txBody>
+                  <a:tcPr anchor="ctr" marL="73152" marR="73152" marT="27432" marB="27432">
+                    <a:solidFill>
+                      <a:srgbClr val="F5F0FC"/>
+                    </a:solidFill>
+                  </a:tcPr>
+                </a:tc>
+                <a:tc>
+                  <a:txBody>
+                    <a:bodyPr/>
+                    <a:lstStyle/>
+                    <a:p>
+                      <a:pPr algn="ctr"/>
+                      <a:r>
+                        <a:rPr sz="1100" b="0">
+                          <a:solidFill>
+                            <a:srgbClr val="3A3A4A"/>
+                          </a:solidFill>
+                          <a:latin typeface="Calibri"/>
+                        </a:rPr>
+                        <a:t>128</a:t>
                       </a:r>
                     </a:p>
                   </a:txBody>
@@ -10499,7 +10499,7 @@
                           </a:solidFill>
                           <a:latin typeface="Calibri"/>
                         </a:rPr>
-                        <a:t>67</a:t>
+                        <a:t>68</a:t>
                       </a:r>
                     </a:p>
                   </a:txBody>
@@ -10662,7 +10662,7 @@
                           </a:solidFill>
                           <a:latin typeface="Calibri"/>
                         </a:rPr>
-                        <a:t>134</a:t>
+                        <a:t>136</a:t>
                       </a:r>
                     </a:p>
                   </a:txBody>
@@ -10965,53 +10965,53 @@
                           </a:solidFill>
                           <a:latin typeface="Calibri"/>
                         </a:rPr>
-                        <a:t>234</a:t>
-                      </a:r>
-                    </a:p>
-                  </a:txBody>
-                  <a:tcPr anchor="ctr" marL="73152" marR="73152" marT="27432" marB="27432">
-                    <a:solidFill>
-                      <a:srgbClr val="F5F0FC"/>
-                    </a:solidFill>
-                  </a:tcPr>
-                </a:tc>
-                <a:tc>
-                  <a:txBody>
-                    <a:bodyPr/>
-                    <a:lstStyle/>
-                    <a:p>
-                      <a:pPr algn="ctr"/>
-                      <a:r>
-                        <a:rPr sz="1100" b="0">
-                          <a:solidFill>
-                            <a:srgbClr val="3A3A4A"/>
-                          </a:solidFill>
-                          <a:latin typeface="Calibri"/>
-                        </a:rPr>
-                        <a:t>2790</a:t>
-                      </a:r>
-                    </a:p>
-                  </a:txBody>
-                  <a:tcPr anchor="ctr" marL="73152" marR="73152" marT="27432" marB="27432">
-                    <a:solidFill>
-                      <a:srgbClr val="F5F0FC"/>
-                    </a:solidFill>
-                  </a:tcPr>
-                </a:tc>
-                <a:tc>
-                  <a:txBody>
-                    <a:bodyPr/>
-                    <a:lstStyle/>
-                    <a:p>
-                      <a:pPr algn="ctr"/>
-                      <a:r>
-                        <a:rPr sz="1100" b="0">
-                          <a:solidFill>
-                            <a:srgbClr val="3A3A4A"/>
-                          </a:solidFill>
-                          <a:latin typeface="Calibri"/>
-                        </a:rPr>
-                        <a:t>1182</a:t>
+                        <a:t>236</a:t>
+                      </a:r>
+                    </a:p>
+                  </a:txBody>
+                  <a:tcPr anchor="ctr" marL="73152" marR="73152" marT="27432" marB="27432">
+                    <a:solidFill>
+                      <a:srgbClr val="F5F0FC"/>
+                    </a:solidFill>
+                  </a:tcPr>
+                </a:tc>
+                <a:tc>
+                  <a:txBody>
+                    <a:bodyPr/>
+                    <a:lstStyle/>
+                    <a:p>
+                      <a:pPr algn="ctr"/>
+                      <a:r>
+                        <a:rPr sz="1100" b="0">
+                          <a:solidFill>
+                            <a:srgbClr val="3A3A4A"/>
+                          </a:solidFill>
+                          <a:latin typeface="Calibri"/>
+                        </a:rPr>
+                        <a:t>2812</a:t>
+                      </a:r>
+                    </a:p>
+                  </a:txBody>
+                  <a:tcPr anchor="ctr" marL="73152" marR="73152" marT="27432" marB="27432">
+                    <a:solidFill>
+                      <a:srgbClr val="F5F0FC"/>
+                    </a:solidFill>
+                  </a:tcPr>
+                </a:tc>
+                <a:tc>
+                  <a:txBody>
+                    <a:bodyPr/>
+                    <a:lstStyle/>
+                    <a:p>
+                      <a:pPr algn="ctr"/>
+                      <a:r>
+                        <a:rPr sz="1100" b="0">
+                          <a:solidFill>
+                            <a:srgbClr val="3A3A4A"/>
+                          </a:solidFill>
+                          <a:latin typeface="Calibri"/>
+                        </a:rPr>
+                        <a:t>1192</a:t>
                       </a:r>
                     </a:p>
                   </a:txBody>
@@ -11168,7 +11168,7 @@
                 </a:solidFill>
                 <a:latin typeface="Calibri"/>
               </a:rPr>
-              <a:t>Source: Metabase Card 6472 + HubSpot  ·  May 29, 2026</a:t>
+              <a:t>Source: Metabase Card 6472 + HubSpot  ·  May 30, 2026</a:t>
             </a:r>
           </a:p>
         </p:txBody>
@@ -11307,7 +11307,7 @@
                 </a:solidFill>
                 <a:latin typeface="Calibri"/>
               </a:rPr>
-              <a:t>Ranked by Volume  |  541 agencies  |  2026 YTD</a:t>
+              <a:t>Ranked by Volume  |  544 agencies  |  2026 YTD</a:t>
             </a:r>
           </a:p>
         </p:txBody>
@@ -11605,7 +11605,7 @@
                           </a:solidFill>
                           <a:latin typeface="Calibri"/>
                         </a:rPr>
-                        <a:t>1695</a:t>
+                        <a:t>1703</a:t>
                       </a:r>
                     </a:p>
                   </a:txBody>
@@ -11628,7 +11628,7 @@
                           </a:solidFill>
                           <a:latin typeface="Calibri"/>
                         </a:rPr>
-                        <a:t>629</a:t>
+                        <a:t>633</a:t>
                       </a:r>
                     </a:p>
                   </a:txBody>
@@ -11768,7 +11768,7 @@
                           </a:solidFill>
                           <a:latin typeface="Calibri"/>
                         </a:rPr>
-                        <a:t>444</a:t>
+                        <a:t>448</a:t>
                       </a:r>
                     </a:p>
                   </a:txBody>
@@ -11791,7 +11791,7 @@
                           </a:solidFill>
                           <a:latin typeface="Calibri"/>
                         </a:rPr>
-                        <a:t>169</a:t>
+                        <a:t>170</a:t>
                       </a:r>
                     </a:p>
                   </a:txBody>
@@ -11931,7 +11931,7 @@
                           </a:solidFill>
                           <a:latin typeface="Calibri"/>
                         </a:rPr>
-                        <a:t>234</a:t>
+                        <a:t>241</a:t>
                       </a:r>
                     </a:p>
                   </a:txBody>
@@ -11954,7 +11954,7 @@
                           </a:solidFill>
                           <a:latin typeface="Calibri"/>
                         </a:rPr>
-                        <a:t>125</a:t>
+                        <a:t>128</a:t>
                       </a:r>
                     </a:p>
                   </a:txBody>
@@ -12000,7 +12000,7 @@
                           </a:solidFill>
                           <a:latin typeface="Calibri"/>
                         </a:rPr>
-                        <a:t>2.6%</a:t>
+                        <a:t>2.5%</a:t>
                       </a:r>
                     </a:p>
                   </a:txBody>
@@ -12094,7 +12094,7 @@
                           </a:solidFill>
                           <a:latin typeface="Calibri"/>
                         </a:rPr>
-                        <a:t>217</a:t>
+                        <a:t>221</a:t>
                       </a:r>
                     </a:p>
                   </a:txBody>
@@ -12117,7 +12117,7 @@
                           </a:solidFill>
                           <a:latin typeface="Calibri"/>
                         </a:rPr>
-                        <a:t>81</a:t>
+                        <a:t>83</a:t>
                       </a:r>
                     </a:p>
                   </a:txBody>
@@ -12163,7 +12163,7 @@
                           </a:solidFill>
                           <a:latin typeface="Calibri"/>
                         </a:rPr>
-                        <a:t>6.0%</a:t>
+                        <a:t>5.9%</a:t>
                       </a:r>
                     </a:p>
                   </a:txBody>
@@ -12257,7 +12257,7 @@
                           </a:solidFill>
                           <a:latin typeface="Calibri"/>
                         </a:rPr>
-                        <a:t>214</a:t>
+                        <a:t>217</a:t>
                       </a:r>
                     </a:p>
                   </a:txBody>
@@ -12280,7 +12280,7 @@
                           </a:solidFill>
                           <a:latin typeface="Calibri"/>
                         </a:rPr>
-                        <a:t>90</a:t>
+                        <a:t>91</a:t>
                       </a:r>
                     </a:p>
                   </a:txBody>
@@ -12326,7 +12326,7 @@
                           </a:solidFill>
                           <a:latin typeface="Calibri"/>
                         </a:rPr>
-                        <a:t>3.3%</a:t>
+                        <a:t>3.2%</a:t>
                       </a:r>
                     </a:p>
                   </a:txBody>
@@ -12583,7 +12583,7 @@
                           </a:solidFill>
                           <a:latin typeface="Calibri"/>
                         </a:rPr>
-                        <a:t>163</a:t>
+                        <a:t>165</a:t>
                       </a:r>
                     </a:p>
                   </a:txBody>
@@ -12606,7 +12606,7 @@
                           </a:solidFill>
                           <a:latin typeface="Calibri"/>
                         </a:rPr>
-                        <a:t>44</a:t>
+                        <a:t>46</a:t>
                       </a:r>
                     </a:p>
                   </a:txBody>
@@ -12746,7 +12746,7 @@
                           </a:solidFill>
                           <a:latin typeface="Calibri"/>
                         </a:rPr>
-                        <a:t>152</a:t>
+                        <a:t>154</a:t>
                       </a:r>
                     </a:p>
                   </a:txBody>
@@ -12769,7 +12769,7 @@
                           </a:solidFill>
                           <a:latin typeface="Calibri"/>
                         </a:rPr>
-                        <a:t>71</a:t>
+                        <a:t>72</a:t>
                       </a:r>
                     </a:p>
                   </a:txBody>
@@ -12815,7 +12815,7 @@
                           </a:solidFill>
                           <a:latin typeface="Calibri"/>
                         </a:rPr>
-                        <a:t>5.3%</a:t>
+                        <a:t>5.2%</a:t>
                       </a:r>
                     </a:p>
                   </a:txBody>
@@ -12909,7 +12909,7 @@
                           </a:solidFill>
                           <a:latin typeface="Calibri"/>
                         </a:rPr>
-                        <a:t>139</a:t>
+                        <a:t>140</a:t>
                       </a:r>
                     </a:p>
                   </a:txBody>
@@ -12932,7 +12932,7 @@
                           </a:solidFill>
                           <a:latin typeface="Calibri"/>
                         </a:rPr>
-                        <a:t>79</a:t>
+                        <a:t>80</a:t>
                       </a:r>
                     </a:p>
                   </a:txBody>
@@ -12978,7 +12978,7 @@
                           </a:solidFill>
                           <a:latin typeface="Calibri"/>
                         </a:rPr>
-                        <a:t>2.2%</a:t>
+                        <a:t>2.1%</a:t>
                       </a:r>
                     </a:p>
                   </a:txBody>
@@ -13421,7 +13421,7 @@
                           </a:solidFill>
                           <a:latin typeface="Calibri"/>
                         </a:rPr>
-                        <a:t>51</a:t>
+                        <a:t>52</a:t>
                       </a:r>
                     </a:p>
                   </a:txBody>
@@ -13561,7 +13561,7 @@
                           </a:solidFill>
                           <a:latin typeface="Calibri"/>
                         </a:rPr>
-                        <a:t>89</a:t>
+                        <a:t>90</a:t>
                       </a:r>
                     </a:p>
                   </a:txBody>
@@ -13630,7 +13630,7 @@
                           </a:solidFill>
                           <a:latin typeface="Calibri"/>
                         </a:rPr>
-                        <a:t>3.4%</a:t>
+                        <a:t>3.3%</a:t>
                       </a:r>
                     </a:p>
                   </a:txBody>
@@ -13724,7 +13724,7 @@
                           </a:solidFill>
                           <a:latin typeface="Calibri"/>
                         </a:rPr>
-                        <a:t>80</a:t>
+                        <a:t>82</a:t>
                       </a:r>
                     </a:p>
                   </a:txBody>
@@ -14376,7 +14376,7 @@
                           </a:solidFill>
                           <a:latin typeface="Calibri"/>
                         </a:rPr>
-                        <a:t>61</a:t>
+                        <a:t>62</a:t>
                       </a:r>
                     </a:p>
                   </a:txBody>
@@ -14445,7 +14445,7 @@
                           </a:solidFill>
                           <a:latin typeface="Calibri"/>
                         </a:rPr>
-                        <a:t>4.9%</a:t>
+                        <a:t>4.8%</a:t>
                       </a:r>
                     </a:p>
                   </a:txBody>
@@ -14656,7 +14656,7 @@
                           </a:solidFill>
                           <a:latin typeface="Calibri"/>
                         </a:rPr>
-                        <a:t>Fast Insurance And Tax Services, Inc.</a:t>
+                        <a:t>H2O Commercial Insurance Agency Corp</a:t>
                       </a:r>
                     </a:p>
                   </a:txBody>
@@ -14679,7 +14679,7 @@
                           </a:solidFill>
                           <a:latin typeface="Calibri"/>
                         </a:rPr>
-                        <a:t>—</a:t>
+                        <a:t>Kurt Butterfield</a:t>
                       </a:r>
                     </a:p>
                   </a:txBody>
@@ -14702,7 +14702,7 @@
                           </a:solidFill>
                           <a:latin typeface="Calibri"/>
                         </a:rPr>
-                        <a:t>57</a:t>
+                        <a:t>59</a:t>
                       </a:r>
                     </a:p>
                   </a:txBody>
@@ -14725,7 +14725,7 @@
                           </a:solidFill>
                           <a:latin typeface="Calibri"/>
                         </a:rPr>
-                        <a:t>14</a:t>
+                        <a:t>24</a:t>
                       </a:r>
                     </a:p>
                   </a:txBody>
@@ -14748,7 +14748,7 @@
                           </a:solidFill>
                           <a:latin typeface="Calibri"/>
                         </a:rPr>
-                        <a:t>0</a:t>
+                        <a:t>1</a:t>
                       </a:r>
                     </a:p>
                   </a:txBody>
@@ -14771,7 +14771,7 @@
                           </a:solidFill>
                           <a:latin typeface="Calibri"/>
                         </a:rPr>
-                        <a:t>0.0%</a:t>
+                        <a:t>1.7%</a:t>
                       </a:r>
                     </a:p>
                   </a:txBody>
@@ -14794,7 +14794,7 @@
                           </a:solidFill>
                           <a:latin typeface="Calibri"/>
                         </a:rPr>
-                        <a:t>$0</a:t>
+                        <a:t>$20,481</a:t>
                       </a:r>
                     </a:p>
                   </a:txBody>
@@ -14819,7 +14819,7 @@
                           </a:solidFill>
                           <a:latin typeface="Calibri"/>
                         </a:rPr>
-                        <a:t>H2O Commercial Insurance Agency Corp</a:t>
+                        <a:t>Fast Insurance And Tax Services, Inc.</a:t>
                       </a:r>
                     </a:p>
                   </a:txBody>
@@ -14842,7 +14842,7 @@
                           </a:solidFill>
                           <a:latin typeface="Calibri"/>
                         </a:rPr>
-                        <a:t>Kurt Butterfield</a:t>
+                        <a:t>—</a:t>
                       </a:r>
                     </a:p>
                   </a:txBody>
@@ -14888,7 +14888,7 @@
                           </a:solidFill>
                           <a:latin typeface="Calibri"/>
                         </a:rPr>
-                        <a:t>24</a:t>
+                        <a:t>14</a:t>
                       </a:r>
                     </a:p>
                   </a:txBody>
@@ -14911,7 +14911,7 @@
                           </a:solidFill>
                           <a:latin typeface="Calibri"/>
                         </a:rPr>
-                        <a:t>1</a:t>
+                        <a:t>0</a:t>
                       </a:r>
                     </a:p>
                   </a:txBody>
@@ -14934,7 +14934,7 @@
                           </a:solidFill>
                           <a:latin typeface="Calibri"/>
                         </a:rPr>
-                        <a:t>1.8%</a:t>
+                        <a:t>0.0%</a:t>
                       </a:r>
                     </a:p>
                   </a:txBody>
@@ -14957,7 +14957,7 @@
                           </a:solidFill>
                           <a:latin typeface="Calibri"/>
                         </a:rPr>
-                        <a:t>$20,481</a:t>
+                        <a:t>$0</a:t>
                       </a:r>
                     </a:p>
                   </a:txBody>
@@ -15165,7 +15165,7 @@
                 </a:solidFill>
                 <a:latin typeface="Calibri"/>
               </a:rPr>
-              <a:t>Showing top 22 of 541 agencies by submission volume  ·  Full list in DSG YTD Word Report</a:t>
+              <a:t>Showing top 22 of 544 agencies by submission volume  ·  Full list in DSG YTD Word Report</a:t>
             </a:r>
           </a:p>
         </p:txBody>
@@ -15243,7 +15243,7 @@
                 </a:solidFill>
                 <a:latin typeface="Calibri"/>
               </a:rPr>
-              <a:t>Source: Metabase Card 6472  ·  May 29, 2026</a:t>
+              <a:t>Source: Metabase Card 6472  ·  May 30, 2026</a:t>
             </a:r>
           </a:p>
         </p:txBody>
@@ -15703,7 +15703,7 @@
                           </a:solidFill>
                           <a:latin typeface="Calibri"/>
                         </a:rPr>
-                        <a:t>3,855</a:t>
+                        <a:t>3,897</a:t>
                       </a:r>
                     </a:p>
                   </a:txBody>
@@ -15772,7 +15772,7 @@
                           </a:solidFill>
                           <a:latin typeface="Calibri"/>
                         </a:rPr>
-                        <a:t>48.9%</a:t>
+                        <a:t>48.3%</a:t>
                       </a:r>
                     </a:p>
                   </a:txBody>
@@ -15843,99 +15843,99 @@
                           </a:solidFill>
                           <a:latin typeface="Calibri"/>
                         </a:rPr>
-                        <a:t>43</a:t>
-                      </a:r>
-                    </a:p>
-                  </a:txBody>
-                  <a:tcPr anchor="ctr" marL="73152" marR="73152" marT="27432" marB="27432">
-                    <a:solidFill>
-                      <a:srgbClr val="EDE8F8"/>
-                    </a:solidFill>
-                  </a:tcPr>
-                </a:tc>
-                <a:tc>
-                  <a:txBody>
-                    <a:bodyPr/>
-                    <a:lstStyle/>
-                    <a:p>
-                      <a:pPr algn="ctr"/>
-                      <a:r>
-                        <a:rPr sz="1100" b="0">
-                          <a:solidFill>
-                            <a:srgbClr val="3A3A4A"/>
-                          </a:solidFill>
-                          <a:latin typeface="Calibri"/>
-                        </a:rPr>
-                        <a:t>1,295</a:t>
-                      </a:r>
-                    </a:p>
-                  </a:txBody>
-                  <a:tcPr anchor="ctr" marL="73152" marR="73152" marT="27432" marB="27432">
-                    <a:solidFill>
-                      <a:srgbClr val="EDE8F8"/>
-                    </a:solidFill>
-                  </a:tcPr>
-                </a:tc>
-                <a:tc>
-                  <a:txBody>
-                    <a:bodyPr/>
-                    <a:lstStyle/>
-                    <a:p>
-                      <a:pPr algn="ctr"/>
-                      <a:r>
-                        <a:rPr sz="1100" b="0">
-                          <a:solidFill>
-                            <a:srgbClr val="3A3A4A"/>
-                          </a:solidFill>
-                          <a:latin typeface="Calibri"/>
-                        </a:rPr>
-                        <a:t>3.3%</a:t>
-                      </a:r>
-                    </a:p>
-                  </a:txBody>
-                  <a:tcPr anchor="ctr" marL="73152" marR="73152" marT="27432" marB="27432">
-                    <a:solidFill>
-                      <a:srgbClr val="EDE8F8"/>
-                    </a:solidFill>
-                  </a:tcPr>
-                </a:tc>
-                <a:tc>
-                  <a:txBody>
-                    <a:bodyPr/>
-                    <a:lstStyle/>
-                    <a:p>
-                      <a:pPr algn="ctr"/>
-                      <a:r>
-                        <a:rPr sz="1100" b="0">
-                          <a:solidFill>
-                            <a:srgbClr val="3A3A4A"/>
-                          </a:solidFill>
-                          <a:latin typeface="Calibri"/>
-                        </a:rPr>
-                        <a:t>$1,239,834</a:t>
-                      </a:r>
-                    </a:p>
-                  </a:txBody>
-                  <a:tcPr anchor="ctr" marL="73152" marR="73152" marT="27432" marB="27432">
-                    <a:solidFill>
-                      <a:srgbClr val="EDE8F8"/>
-                    </a:solidFill>
-                  </a:tcPr>
-                </a:tc>
-                <a:tc>
-                  <a:txBody>
-                    <a:bodyPr/>
-                    <a:lstStyle/>
-                    <a:p>
-                      <a:pPr algn="ctr"/>
-                      <a:r>
-                        <a:rPr sz="1100" b="0">
-                          <a:solidFill>
-                            <a:srgbClr val="3A3A4A"/>
-                          </a:solidFill>
-                          <a:latin typeface="Calibri"/>
-                        </a:rPr>
-                        <a:t>24.4%</a:t>
+                        <a:t>45</a:t>
+                      </a:r>
+                    </a:p>
+                  </a:txBody>
+                  <a:tcPr anchor="ctr" marL="73152" marR="73152" marT="27432" marB="27432">
+                    <a:solidFill>
+                      <a:srgbClr val="EDE8F8"/>
+                    </a:solidFill>
+                  </a:tcPr>
+                </a:tc>
+                <a:tc>
+                  <a:txBody>
+                    <a:bodyPr/>
+                    <a:lstStyle/>
+                    <a:p>
+                      <a:pPr algn="ctr"/>
+                      <a:r>
+                        <a:rPr sz="1100" b="0">
+                          <a:solidFill>
+                            <a:srgbClr val="3A3A4A"/>
+                          </a:solidFill>
+                          <a:latin typeface="Calibri"/>
+                        </a:rPr>
+                        <a:t>1,309</a:t>
+                      </a:r>
+                    </a:p>
+                  </a:txBody>
+                  <a:tcPr anchor="ctr" marL="73152" marR="73152" marT="27432" marB="27432">
+                    <a:solidFill>
+                      <a:srgbClr val="EDE8F8"/>
+                    </a:solidFill>
+                  </a:tcPr>
+                </a:tc>
+                <a:tc>
+                  <a:txBody>
+                    <a:bodyPr/>
+                    <a:lstStyle/>
+                    <a:p>
+                      <a:pPr algn="ctr"/>
+                      <a:r>
+                        <a:rPr sz="1100" b="0">
+                          <a:solidFill>
+                            <a:srgbClr val="3A3A4A"/>
+                          </a:solidFill>
+                          <a:latin typeface="Calibri"/>
+                        </a:rPr>
+                        <a:t>3.4%</a:t>
+                      </a:r>
+                    </a:p>
+                  </a:txBody>
+                  <a:tcPr anchor="ctr" marL="73152" marR="73152" marT="27432" marB="27432">
+                    <a:solidFill>
+                      <a:srgbClr val="EDE8F8"/>
+                    </a:solidFill>
+                  </a:tcPr>
+                </a:tc>
+                <a:tc>
+                  <a:txBody>
+                    <a:bodyPr/>
+                    <a:lstStyle/>
+                    <a:p>
+                      <a:pPr algn="ctr"/>
+                      <a:r>
+                        <a:rPr sz="1100" b="0">
+                          <a:solidFill>
+                            <a:srgbClr val="3A3A4A"/>
+                          </a:solidFill>
+                          <a:latin typeface="Calibri"/>
+                        </a:rPr>
+                        <a:t>$1,337,183</a:t>
+                      </a:r>
+                    </a:p>
+                  </a:txBody>
+                  <a:tcPr anchor="ctr" marL="73152" marR="73152" marT="27432" marB="27432">
+                    <a:solidFill>
+                      <a:srgbClr val="EDE8F8"/>
+                    </a:solidFill>
+                  </a:tcPr>
+                </a:tc>
+                <a:tc>
+                  <a:txBody>
+                    <a:bodyPr/>
+                    <a:lstStyle/>
+                    <a:p>
+                      <a:pPr algn="ctr"/>
+                      <a:r>
+                        <a:rPr sz="1100" b="0">
+                          <a:solidFill>
+                            <a:srgbClr val="3A3A4A"/>
+                          </a:solidFill>
+                          <a:latin typeface="Calibri"/>
+                        </a:rPr>
+                        <a:t>26.0%</a:t>
                       </a:r>
                     </a:p>
                   </a:txBody>
@@ -16029,30 +16029,30 @@
                           </a:solidFill>
                           <a:latin typeface="Calibri"/>
                         </a:rPr>
-                        <a:t>275</a:t>
-                      </a:r>
-                    </a:p>
-                  </a:txBody>
-                  <a:tcPr anchor="ctr" marL="73152" marR="73152" marT="27432" marB="27432">
-                    <a:solidFill>
-                      <a:srgbClr val="F5F0FC"/>
-                    </a:solidFill>
-                  </a:tcPr>
-                </a:tc>
-                <a:tc>
-                  <a:txBody>
-                    <a:bodyPr/>
-                    <a:lstStyle/>
-                    <a:p>
-                      <a:pPr algn="ctr"/>
-                      <a:r>
-                        <a:rPr sz="1100" b="0">
-                          <a:solidFill>
-                            <a:srgbClr val="3A3A4A"/>
-                          </a:solidFill>
-                          <a:latin typeface="Calibri"/>
-                        </a:rPr>
-                        <a:t>2.9%</a:t>
+                        <a:t>281</a:t>
+                      </a:r>
+                    </a:p>
+                  </a:txBody>
+                  <a:tcPr anchor="ctr" marL="73152" marR="73152" marT="27432" marB="27432">
+                    <a:solidFill>
+                      <a:srgbClr val="F5F0FC"/>
+                    </a:solidFill>
+                  </a:tcPr>
+                </a:tc>
+                <a:tc>
+                  <a:txBody>
+                    <a:bodyPr/>
+                    <a:lstStyle/>
+                    <a:p>
+                      <a:pPr algn="ctr"/>
+                      <a:r>
+                        <a:rPr sz="1100" b="0">
+                          <a:solidFill>
+                            <a:srgbClr val="3A3A4A"/>
+                          </a:solidFill>
+                          <a:latin typeface="Calibri"/>
+                        </a:rPr>
+                        <a:t>2.8%</a:t>
                       </a:r>
                     </a:p>
                   </a:txBody>
@@ -16098,7 +16098,7 @@
                           </a:solidFill>
                           <a:latin typeface="Calibri"/>
                         </a:rPr>
-                        <a:t>6.5%</a:t>
+                        <a:t>6.4%</a:t>
                       </a:r>
                     </a:p>
                   </a:txBody>
@@ -16192,30 +16192,30 @@
                           </a:solidFill>
                           <a:latin typeface="Calibri"/>
                         </a:rPr>
-                        <a:t>92</a:t>
-                      </a:r>
-                    </a:p>
-                  </a:txBody>
-                  <a:tcPr anchor="ctr" marL="73152" marR="73152" marT="27432" marB="27432">
-                    <a:solidFill>
-                      <a:srgbClr val="EDE8F8"/>
-                    </a:solidFill>
-                  </a:tcPr>
-                </a:tc>
-                <a:tc>
-                  <a:txBody>
-                    <a:bodyPr/>
-                    <a:lstStyle/>
-                    <a:p>
-                      <a:pPr algn="ctr"/>
-                      <a:r>
-                        <a:rPr sz="1100" b="0">
-                          <a:solidFill>
-                            <a:srgbClr val="3A3A4A"/>
-                          </a:solidFill>
-                          <a:latin typeface="Calibri"/>
-                        </a:rPr>
-                        <a:t>5.4%</a:t>
+                        <a:t>94</a:t>
+                      </a:r>
+                    </a:p>
+                  </a:txBody>
+                  <a:tcPr anchor="ctr" marL="73152" marR="73152" marT="27432" marB="27432">
+                    <a:solidFill>
+                      <a:srgbClr val="EDE8F8"/>
+                    </a:solidFill>
+                  </a:tcPr>
+                </a:tc>
+                <a:tc>
+                  <a:txBody>
+                    <a:bodyPr/>
+                    <a:lstStyle/>
+                    <a:p>
+                      <a:pPr algn="ctr"/>
+                      <a:r>
+                        <a:rPr sz="1100" b="0">
+                          <a:solidFill>
+                            <a:srgbClr val="3A3A4A"/>
+                          </a:solidFill>
+                          <a:latin typeface="Calibri"/>
+                        </a:rPr>
+                        <a:t>5.3%</a:t>
                       </a:r>
                     </a:p>
                   </a:txBody>
@@ -16355,7 +16355,7 @@
                           </a:solidFill>
                           <a:latin typeface="Calibri"/>
                         </a:rPr>
-                        <a:t>85</a:t>
+                        <a:t>86</a:t>
                       </a:r>
                     </a:p>
                   </a:txBody>
@@ -16518,7 +16518,7 @@
                           </a:solidFill>
                           <a:latin typeface="Calibri"/>
                         </a:rPr>
-                        <a:t>88</a:t>
+                        <a:t>89</a:t>
                       </a:r>
                     </a:p>
                   </a:txBody>
@@ -16844,7 +16844,7 @@
                           </a:solidFill>
                           <a:latin typeface="Calibri"/>
                         </a:rPr>
-                        <a:t>74</a:t>
+                        <a:t>75</a:t>
                       </a:r>
                     </a:p>
                   </a:txBody>
@@ -18148,7 +18148,7 @@
                           </a:solidFill>
                           <a:latin typeface="Calibri"/>
                         </a:rPr>
-                        <a:t>122</a:t>
+                        <a:t>124</a:t>
                       </a:r>
                     </a:p>
                   </a:txBody>
@@ -19452,7 +19452,7 @@
                           </a:solidFill>
                           <a:latin typeface="Calibri"/>
                         </a:rPr>
-                        <a:t>58</a:t>
+                        <a:t>59</a:t>
                       </a:r>
                     </a:p>
                   </a:txBody>
@@ -19609,7 +19609,7 @@
                 </a:solidFill>
                 <a:latin typeface="Calibri"/>
               </a:rPr>
-              <a:t>Source: Metabase Card 6472  ·  May 29, 2026</a:t>
+              <a:t>Source: Metabase Card 6472  ·  May 30, 2026</a:t>
             </a:r>
           </a:p>
         </p:txBody>
@@ -19982,7 +19982,7 @@
                 </a:solidFill>
                 <a:latin typeface="Calibri"/>
               </a:rPr>
-              <a:t>$3,964,966  (78%)</a:t>
+              <a:t>$4,057,281  (79%)</a:t>
             </a:r>
           </a:p>
         </p:txBody>
@@ -20095,7 +20095,7 @@
                 </a:solidFill>
                 <a:latin typeface="Calibri"/>
               </a:rPr>
-              <a:t>$504,686  (10%)</a:t>
+              <a:t>$509,170  (10%)</a:t>
             </a:r>
           </a:p>
         </p:txBody>
@@ -20208,7 +20208,7 @@
                 </a:solidFill>
                 <a:latin typeface="Calibri"/>
               </a:rPr>
-              <a:t>$605,666  (12%)</a:t>
+              <a:t>$573,828  (11%)</a:t>
             </a:r>
           </a:p>
         </p:txBody>
@@ -20399,7 +20399,7 @@
                 </a:solidFill>
                 <a:latin typeface="Calibri"/>
               </a:rPr>
-              <a:t>99</a:t>
+              <a:t>100</a:t>
             </a:r>
           </a:p>
         </p:txBody>
@@ -20434,7 +20434,7 @@
                 </a:solidFill>
                 <a:latin typeface="Calibri"/>
               </a:rPr>
-              <a:t>$2,656,103  (52%)</a:t>
+              <a:t>$2,721,064  (53%)</a:t>
             </a:r>
           </a:p>
         </p:txBody>
@@ -20547,7 +20547,7 @@
                 </a:solidFill>
                 <a:latin typeface="Calibri"/>
               </a:rPr>
-              <a:t>39</a:t>
+              <a:t>40</a:t>
             </a:r>
           </a:p>
         </p:txBody>
@@ -20582,7 +20582,7 @@
                 </a:solidFill>
                 <a:latin typeface="Calibri"/>
               </a:rPr>
-              <a:t>$1,097,090  (22%)</a:t>
+              <a:t>$1,129,478  (22%)</a:t>
             </a:r>
           </a:p>
         </p:txBody>
@@ -21069,7 +21069,7 @@
                 </a:solidFill>
                 <a:latin typeface="Calibri"/>
               </a:rPr>
-              <a:t>117 accounts  (71%)</a:t>
+              <a:t>118 accounts  (71%)</a:t>
             </a:r>
           </a:p>
         </p:txBody>
@@ -21408,7 +21408,7 @@
                 </a:solidFill>
                 <a:latin typeface="Calibri"/>
               </a:rPr>
-              <a:t>10 accounts  (6%)</a:t>
+              <a:t>11 accounts  (7%)</a:t>
             </a:r>
           </a:p>
         </p:txBody>
@@ -21599,7 +21599,7 @@
                 </a:solidFill>
                 <a:latin typeface="Calibri Light"/>
               </a:rPr>
-              <a:t>Average Fleet Size: 1.8 units/account  ·  Total Units: 299</a:t>
+              <a:t>Average Fleet Size: 1.8 units/account  ·  Total Units: 304</a:t>
             </a:r>
           </a:p>
         </p:txBody>
@@ -21790,7 +21790,7 @@
                 </a:solidFill>
                 <a:latin typeface="Calibri"/>
               </a:rPr>
-              <a:t>$26,829 avg  ·  99 accts</a:t>
+              <a:t>$27,211 avg  ·  100 accts</a:t>
             </a:r>
           </a:p>
         </p:txBody>
@@ -21903,7 +21903,7 @@
                 </a:solidFill>
                 <a:latin typeface="Calibri"/>
               </a:rPr>
-              <a:t>$28,131 avg  ·  39 accts</a:t>
+              <a:t>$28,237 avg  ·  40 accts</a:t>
             </a:r>
           </a:p>
         </p:txBody>
@@ -22207,7 +22207,7 @@
                 </a:solidFill>
                 <a:latin typeface="Calibri"/>
               </a:rPr>
-              <a:t>Source: Metabase Card 6472  ·  May 29, 2026</a:t>
+              <a:t>Source: Metabase Card 6472  ·  May 30, 2026</a:t>
             </a:r>
           </a:p>
         </p:txBody>
@@ -22389,7 +22389,7 @@
                 </a:solidFill>
                 <a:latin typeface="Calibri"/>
               </a:rPr>
-              <a:t>164 unique accounts bound YTD — most recent first</a:t>
+              <a:t>166 unique accounts bound YTD — most recent first</a:t>
             </a:r>
           </a:p>
         </p:txBody>
@@ -22737,7 +22737,7 @@
                           </a:solidFill>
                           <a:latin typeface="Calibri"/>
                         </a:rPr>
-                        <a:t>MARK STANFORD</a:t>
+                        <a:t>911 TRUCKING LLC</a:t>
                       </a:r>
                     </a:p>
                   </a:txBody>
@@ -22760,7 +22760,7 @@
                           </a:solidFill>
                           <a:latin typeface="Calibri"/>
                         </a:rPr>
-                        <a:t>Palerm Insurance Agency LLC</a:t>
+                        <a:t>Checkers Truck Insurance Services</a:t>
                       </a:r>
                     </a:p>
                   </a:txBody>
@@ -22783,7 +22783,7 @@
                           </a:solidFill>
                           <a:latin typeface="Calibri"/>
                         </a:rPr>
-                        <a:t>—</a:t>
+                        <a:t>Derek Janssen</a:t>
                       </a:r>
                     </a:p>
                   </a:txBody>
@@ -22806,7 +22806,7 @@
                           </a:solidFill>
                           <a:latin typeface="Calibri"/>
                         </a:rPr>
-                        <a:t>TX</a:t>
+                        <a:t>CA</a:t>
                       </a:r>
                     </a:p>
                   </a:txBody>
@@ -22829,7 +22829,7 @@
                           </a:solidFill>
                           <a:latin typeface="Calibri"/>
                         </a:rPr>
-                        <a:t>$32,699</a:t>
+                        <a:t>$32,388</a:t>
                       </a:r>
                     </a:p>
                   </a:txBody>
@@ -22854,7 +22854,7 @@
                           </a:solidFill>
                           <a:latin typeface="Calibri"/>
                         </a:rPr>
-                        <a:t>2026-05-21</a:t>
+                        <a:t>2026-05-27</a:t>
                       </a:r>
                     </a:p>
                   </a:txBody>
@@ -22877,7 +22877,7 @@
                           </a:solidFill>
                           <a:latin typeface="Calibri"/>
                         </a:rPr>
-                        <a:t>GERARDO CARRANCO GOMEZ</a:t>
+                        <a:t>MARK STANFORD</a:t>
                       </a:r>
                     </a:p>
                   </a:txBody>
@@ -22900,7 +22900,7 @@
                           </a:solidFill>
                           <a:latin typeface="Calibri"/>
                         </a:rPr>
-                        <a:t>ECO INSURANCE SERVICES</a:t>
+                        <a:t>Palerm Insurance Agency LLC</a:t>
                       </a:r>
                     </a:p>
                   </a:txBody>
@@ -22923,7 +22923,7 @@
                           </a:solidFill>
                           <a:latin typeface="Calibri"/>
                         </a:rPr>
-                        <a:t>Derrick Leroy</a:t>
+                        <a:t>—</a:t>
                       </a:r>
                     </a:p>
                   </a:txBody>
@@ -22969,7 +22969,7 @@
                           </a:solidFill>
                           <a:latin typeface="Calibri"/>
                         </a:rPr>
-                        <a:t>$11,549</a:t>
+                        <a:t>$32,699</a:t>
                       </a:r>
                     </a:p>
                   </a:txBody>
@@ -23017,7 +23017,7 @@
                           </a:solidFill>
                           <a:latin typeface="Calibri"/>
                         </a:rPr>
-                        <a:t>LEON CALDERON</a:t>
+                        <a:t>GERARDO CARRANCO GOMEZ</a:t>
                       </a:r>
                     </a:p>
                   </a:txBody>
@@ -23040,7 +23040,7 @@
                           </a:solidFill>
                           <a:latin typeface="Calibri"/>
                         </a:rPr>
-                        <a:t>AMC Agents LLC</a:t>
+                        <a:t>ECO INSURANCE SERVICES</a:t>
                       </a:r>
                     </a:p>
                   </a:txBody>
@@ -23109,7 +23109,7 @@
                           </a:solidFill>
                           <a:latin typeface="Calibri"/>
                         </a:rPr>
-                        <a:t>$16,287</a:t>
+                        <a:t>$11,549</a:t>
                       </a:r>
                     </a:p>
                   </a:txBody>
@@ -23134,7 +23134,7 @@
                           </a:solidFill>
                           <a:latin typeface="Calibri"/>
                         </a:rPr>
-                        <a:t>2026-05-20</a:t>
+                        <a:t>2026-05-21</a:t>
                       </a:r>
                     </a:p>
                   </a:txBody>
@@ -23157,7 +23157,7 @@
                           </a:solidFill>
                           <a:latin typeface="Calibri"/>
                         </a:rPr>
-                        <a:t>J HADDEN LOGISTICS LLC</a:t>
+                        <a:t>LEON CALDERON</a:t>
                       </a:r>
                     </a:p>
                   </a:txBody>
@@ -23180,7 +23180,7 @@
                           </a:solidFill>
                           <a:latin typeface="Calibri"/>
                         </a:rPr>
-                        <a:t>The Insurance Store Of Texas LLC</a:t>
+                        <a:t>AMC Agents LLC</a:t>
                       </a:r>
                     </a:p>
                   </a:txBody>
@@ -23203,7 +23203,7 @@
                           </a:solidFill>
                           <a:latin typeface="Calibri"/>
                         </a:rPr>
-                        <a:t>Lydia Ramos</a:t>
+                        <a:t>Derrick Leroy</a:t>
                       </a:r>
                     </a:p>
                   </a:txBody>
@@ -23226,7 +23226,7 @@
                           </a:solidFill>
                           <a:latin typeface="Calibri"/>
                         </a:rPr>
-                        <a:t>GA</a:t>
+                        <a:t>TX</a:t>
                       </a:r>
                     </a:p>
                   </a:txBody>
@@ -23249,7 +23249,7 @@
                           </a:solidFill>
                           <a:latin typeface="Calibri"/>
                         </a:rPr>
-                        <a:t>$2,575</a:t>
+                        <a:t>$16,287</a:t>
                       </a:r>
                     </a:p>
                   </a:txBody>
@@ -23274,7 +23274,7 @@
                           </a:solidFill>
                           <a:latin typeface="Calibri"/>
                         </a:rPr>
-                        <a:t>2026-05-19</a:t>
+                        <a:t>2026-05-20</a:t>
                       </a:r>
                     </a:p>
                   </a:txBody>
@@ -23297,7 +23297,7 @@
                           </a:solidFill>
                           <a:latin typeface="Calibri"/>
                         </a:rPr>
-                        <a:t>VULCAN TRANSPORT US LLC</a:t>
+                        <a:t>J HADDEN LOGISTICS LLC</a:t>
                       </a:r>
                     </a:p>
                   </a:txBody>
@@ -23320,7 +23320,7 @@
                           </a:solidFill>
                           <a:latin typeface="Calibri"/>
                         </a:rPr>
-                        <a:t>Cover Badger LLC</a:t>
+                        <a:t>The Insurance Store Of Texas LLC</a:t>
                       </a:r>
                     </a:p>
                   </a:txBody>
@@ -23343,7 +23343,7 @@
                           </a:solidFill>
                           <a:latin typeface="Calibri"/>
                         </a:rPr>
-                        <a:t>—</a:t>
+                        <a:t>Lydia Ramos</a:t>
                       </a:r>
                     </a:p>
                   </a:txBody>
@@ -23366,7 +23366,7 @@
                           </a:solidFill>
                           <a:latin typeface="Calibri"/>
                         </a:rPr>
-                        <a:t>TX</a:t>
+                        <a:t>GA</a:t>
                       </a:r>
                     </a:p>
                   </a:txBody>
@@ -23389,7 +23389,7 @@
                           </a:solidFill>
                           <a:latin typeface="Calibri"/>
                         </a:rPr>
-                        <a:t>$318,765</a:t>
+                        <a:t>$2,575</a:t>
                       </a:r>
                     </a:p>
                   </a:txBody>
@@ -23414,7 +23414,7 @@
                           </a:solidFill>
                           <a:latin typeface="Calibri"/>
                         </a:rPr>
-                        <a:t>2026-05-18</a:t>
+                        <a:t>2026-05-19</a:t>
                       </a:r>
                     </a:p>
                   </a:txBody>
@@ -23437,7 +23437,7 @@
                           </a:solidFill>
                           <a:latin typeface="Calibri"/>
                         </a:rPr>
-                        <a:t>GRAY-GOLD READY MIX INC</a:t>
+                        <a:t>VULCAN TRANSPORT US LLC</a:t>
                       </a:r>
                     </a:p>
                   </a:txBody>
@@ -23460,7 +23460,7 @@
                           </a:solidFill>
                           <a:latin typeface="Calibri"/>
                         </a:rPr>
-                        <a:t>First Connect Insurance</a:t>
+                        <a:t>Cover Badger LLC</a:t>
                       </a:r>
                     </a:p>
                   </a:txBody>
@@ -23483,7 +23483,7 @@
                           </a:solidFill>
                           <a:latin typeface="Calibri"/>
                         </a:rPr>
-                        <a:t>James Reid</a:t>
+                        <a:t>—</a:t>
                       </a:r>
                     </a:p>
                   </a:txBody>
@@ -23506,7 +23506,7 @@
                           </a:solidFill>
                           <a:latin typeface="Calibri"/>
                         </a:rPr>
-                        <a:t>CA</a:t>
+                        <a:t>TX</a:t>
                       </a:r>
                     </a:p>
                   </a:txBody>
@@ -23529,7 +23529,7 @@
                           </a:solidFill>
                           <a:latin typeface="Calibri"/>
                         </a:rPr>
-                        <a:t>$23,978</a:t>
+                        <a:t>$318,765</a:t>
                       </a:r>
                     </a:p>
                   </a:txBody>
@@ -23577,7 +23577,7 @@
                           </a:solidFill>
                           <a:latin typeface="Calibri"/>
                         </a:rPr>
-                        <a:t>YPV FREIGHT INC</a:t>
+                        <a:t>GRAY-GOLD READY MIX INC</a:t>
                       </a:r>
                     </a:p>
                   </a:txBody>
@@ -23600,7 +23600,7 @@
                           </a:solidFill>
                           <a:latin typeface="Calibri"/>
                         </a:rPr>
-                        <a:t>Ewall Insurance Company</a:t>
+                        <a:t>First Connect Insurance</a:t>
                       </a:r>
                     </a:p>
                   </a:txBody>
@@ -23623,7 +23623,7 @@
                           </a:solidFill>
                           <a:latin typeface="Calibri"/>
                         </a:rPr>
-                        <a:t>Derek Janssen</a:t>
+                        <a:t>James Reid</a:t>
                       </a:r>
                     </a:p>
                   </a:txBody>
@@ -23646,7 +23646,7 @@
                           </a:solidFill>
                           <a:latin typeface="Calibri"/>
                         </a:rPr>
-                        <a:t>NV</a:t>
+                        <a:t>CA</a:t>
                       </a:r>
                     </a:p>
                   </a:txBody>
@@ -23669,7 +23669,7 @@
                           </a:solidFill>
                           <a:latin typeface="Calibri"/>
                         </a:rPr>
-                        <a:t>$3,169</a:t>
+                        <a:t>$23,978</a:t>
                       </a:r>
                     </a:p>
                   </a:txBody>
@@ -23694,7 +23694,7 @@
                           </a:solidFill>
                           <a:latin typeface="Calibri"/>
                         </a:rPr>
-                        <a:t>2026-05-15</a:t>
+                        <a:t>2026-05-18</a:t>
                       </a:r>
                     </a:p>
                   </a:txBody>
@@ -23717,7 +23717,7 @@
                           </a:solidFill>
                           <a:latin typeface="Calibri"/>
                         </a:rPr>
-                        <a:t>G&amp;G DFW LOGISTICS LLC</a:t>
+                        <a:t>YPV FREIGHT INC</a:t>
                       </a:r>
                     </a:p>
                   </a:txBody>
@@ -23740,7 +23740,7 @@
                           </a:solidFill>
                           <a:latin typeface="Calibri"/>
                         </a:rPr>
-                        <a:t>AMC Agents LLC</a:t>
+                        <a:t>Ewall Insurance Company</a:t>
                       </a:r>
                     </a:p>
                   </a:txBody>
@@ -23763,7 +23763,7 @@
                           </a:solidFill>
                           <a:latin typeface="Calibri"/>
                         </a:rPr>
-                        <a:t>Derrick Leroy</a:t>
+                        <a:t>Derek Janssen</a:t>
                       </a:r>
                     </a:p>
                   </a:txBody>
@@ -23786,7 +23786,7 @@
                           </a:solidFill>
                           <a:latin typeface="Calibri"/>
                         </a:rPr>
-                        <a:t>TX</a:t>
+                        <a:t>NV</a:t>
                       </a:r>
                     </a:p>
                   </a:txBody>
@@ -23809,7 +23809,7 @@
                           </a:solidFill>
                           <a:latin typeface="Calibri"/>
                         </a:rPr>
-                        <a:t>$26,835</a:t>
+                        <a:t>$3,169</a:t>
                       </a:r>
                     </a:p>
                   </a:txBody>
@@ -23834,7 +23834,7 @@
                           </a:solidFill>
                           <a:latin typeface="Calibri"/>
                         </a:rPr>
-                        <a:t>2026-05-14</a:t>
+                        <a:t>2026-05-15</a:t>
                       </a:r>
                     </a:p>
                   </a:txBody>
@@ -23857,7 +23857,7 @@
                           </a:solidFill>
                           <a:latin typeface="Calibri"/>
                         </a:rPr>
-                        <a:t>ECL TRUCKING LLC</a:t>
+                        <a:t>G&amp;G DFW LOGISTICS LLC</a:t>
                       </a:r>
                     </a:p>
                   </a:txBody>
@@ -23880,7 +23880,7 @@
                           </a:solidFill>
                           <a:latin typeface="Calibri"/>
                         </a:rPr>
-                        <a:t>Storrs Insurance Group, Inc.</a:t>
+                        <a:t>AMC Agents LLC</a:t>
                       </a:r>
                     </a:p>
                   </a:txBody>
@@ -23903,7 +23903,7 @@
                           </a:solidFill>
                           <a:latin typeface="Calibri"/>
                         </a:rPr>
-                        <a:t>Lydia Ramos</a:t>
+                        <a:t>Derrick Leroy</a:t>
                       </a:r>
                     </a:p>
                   </a:txBody>
@@ -23926,7 +23926,7 @@
                           </a:solidFill>
                           <a:latin typeface="Calibri"/>
                         </a:rPr>
-                        <a:t>CA</a:t>
+                        <a:t>TX</a:t>
                       </a:r>
                     </a:p>
                   </a:txBody>
@@ -23949,7 +23949,7 @@
                           </a:solidFill>
                           <a:latin typeface="Calibri"/>
                         </a:rPr>
-                        <a:t>$21,496</a:t>
+                        <a:t>$26,835</a:t>
                       </a:r>
                     </a:p>
                   </a:txBody>
@@ -23997,7 +23997,7 @@
                           </a:solidFill>
                           <a:latin typeface="Calibri"/>
                         </a:rPr>
-                        <a:t>AUXVAC LLC</a:t>
+                        <a:t>ECL TRUCKING LLC</a:t>
                       </a:r>
                     </a:p>
                   </a:txBody>
@@ -24020,7 +24020,7 @@
                           </a:solidFill>
                           <a:latin typeface="Calibri"/>
                         </a:rPr>
-                        <a:t>Navsav Holdings Ii, LLC</a:t>
+                        <a:t>Storrs Insurance Group, Inc.</a:t>
                       </a:r>
                     </a:p>
                   </a:txBody>
@@ -24043,7 +24043,7 @@
                           </a:solidFill>
                           <a:latin typeface="Calibri"/>
                         </a:rPr>
-                        <a:t>Portia Lewis</a:t>
+                        <a:t>Lydia Ramos</a:t>
                       </a:r>
                     </a:p>
                   </a:txBody>
@@ -24066,7 +24066,7 @@
                           </a:solidFill>
                           <a:latin typeface="Calibri"/>
                         </a:rPr>
-                        <a:t>TX</a:t>
+                        <a:t>CA</a:t>
                       </a:r>
                     </a:p>
                   </a:txBody>
@@ -24089,7 +24089,7 @@
                           </a:solidFill>
                           <a:latin typeface="Calibri"/>
                         </a:rPr>
-                        <a:t>$22,774</a:t>
+                        <a:t>$21,496</a:t>
                       </a:r>
                     </a:p>
                   </a:txBody>
@@ -24137,7 +24137,7 @@
                           </a:solidFill>
                           <a:latin typeface="Calibri"/>
                         </a:rPr>
-                        <a:t>CASTANO CONSTRUCTION LLC</a:t>
+                        <a:t>AUXVAC LLC</a:t>
                       </a:r>
                     </a:p>
                   </a:txBody>
@@ -24160,7 +24160,7 @@
                           </a:solidFill>
                           <a:latin typeface="Calibri"/>
                         </a:rPr>
-                        <a:t>Valion Security LLC</a:t>
+                        <a:t>Navsav Holdings Ii, LLC</a:t>
                       </a:r>
                     </a:p>
                   </a:txBody>
@@ -24183,7 +24183,7 @@
                           </a:solidFill>
                           <a:latin typeface="Calibri"/>
                         </a:rPr>
-                        <a:t>Ron Douglas</a:t>
+                        <a:t>Portia Lewis</a:t>
                       </a:r>
                     </a:p>
                   </a:txBody>
@@ -24229,7 +24229,7 @@
                           </a:solidFill>
                           <a:latin typeface="Calibri"/>
                         </a:rPr>
-                        <a:t>$8,567</a:t>
+                        <a:t>$22,774</a:t>
                       </a:r>
                     </a:p>
                   </a:txBody>
@@ -24254,7 +24254,7 @@
                           </a:solidFill>
                           <a:latin typeface="Calibri"/>
                         </a:rPr>
-                        <a:t>2026-05-13</a:t>
+                        <a:t>2026-05-14</a:t>
                       </a:r>
                     </a:p>
                   </a:txBody>
@@ -24277,7 +24277,7 @@
                           </a:solidFill>
                           <a:latin typeface="Calibri"/>
                         </a:rPr>
-                        <a:t>INEZ FAMILY TRUCKING LLC</a:t>
+                        <a:t>CASTANO CONSTRUCTION LLC</a:t>
                       </a:r>
                     </a:p>
                   </a:txBody>
@@ -24300,7 +24300,7 @@
                           </a:solidFill>
                           <a:latin typeface="Calibri"/>
                         </a:rPr>
-                        <a:t>Justin Robert Insurance Agency LLC</a:t>
+                        <a:t>Valion Security LLC</a:t>
                       </a:r>
                     </a:p>
                   </a:txBody>
@@ -24323,7 +24323,7 @@
                           </a:solidFill>
                           <a:latin typeface="Calibri"/>
                         </a:rPr>
-                        <a:t>Kurt Butterfield</a:t>
+                        <a:t>Ron Douglas</a:t>
                       </a:r>
                     </a:p>
                   </a:txBody>
@@ -24369,7 +24369,7 @@
                           </a:solidFill>
                           <a:latin typeface="Calibri"/>
                         </a:rPr>
-                        <a:t>$18,327</a:t>
+                        <a:t>$8,567</a:t>
                       </a:r>
                     </a:p>
                   </a:txBody>
@@ -24394,7 +24394,7 @@
                           </a:solidFill>
                           <a:latin typeface="Calibri"/>
                         </a:rPr>
-                        <a:t>2026-05-12</a:t>
+                        <a:t>2026-05-13</a:t>
                       </a:r>
                     </a:p>
                   </a:txBody>
@@ -24417,7 +24417,7 @@
                           </a:solidFill>
                           <a:latin typeface="Calibri"/>
                         </a:rPr>
-                        <a:t>ESCAMILLA TRUCKING INC</a:t>
+                        <a:t>INEZ FAMILY TRUCKING LLC</a:t>
                       </a:r>
                     </a:p>
                   </a:txBody>
@@ -24440,7 +24440,7 @@
                           </a:solidFill>
                           <a:latin typeface="Calibri"/>
                         </a:rPr>
-                        <a:t>Cover Badger LLC</a:t>
+                        <a:t>Justin Robert Insurance Agency LLC</a:t>
                       </a:r>
                     </a:p>
                   </a:txBody>
@@ -24463,7 +24463,7 @@
                           </a:solidFill>
                           <a:latin typeface="Calibri"/>
                         </a:rPr>
-                        <a:t>—</a:t>
+                        <a:t>Kurt Butterfield</a:t>
                       </a:r>
                     </a:p>
                   </a:txBody>
@@ -24486,7 +24486,7 @@
                           </a:solidFill>
                           <a:latin typeface="Calibri"/>
                         </a:rPr>
-                        <a:t>CA</a:t>
+                        <a:t>TX</a:t>
                       </a:r>
                     </a:p>
                   </a:txBody>
@@ -24509,7 +24509,7 @@
                           </a:solidFill>
                           <a:latin typeface="Calibri"/>
                         </a:rPr>
-                        <a:t>$39,423</a:t>
+                        <a:t>$18,327</a:t>
                       </a:r>
                     </a:p>
                   </a:txBody>
@@ -24557,7 +24557,7 @@
                           </a:solidFill>
                           <a:latin typeface="Calibri"/>
                         </a:rPr>
-                        <a:t>A &amp; D TRUCKING SERVICES LLC</a:t>
+                        <a:t>ESCAMILLA TRUCKING INC</a:t>
                       </a:r>
                     </a:p>
                   </a:txBody>
@@ -24580,7 +24580,7 @@
                           </a:solidFill>
                           <a:latin typeface="Calibri"/>
                         </a:rPr>
-                        <a:t>PR Risk Management Group Inc.</a:t>
+                        <a:t>Cover Badger LLC</a:t>
                       </a:r>
                     </a:p>
                   </a:txBody>
@@ -24626,7 +24626,7 @@
                           </a:solidFill>
                           <a:latin typeface="Calibri"/>
                         </a:rPr>
-                        <a:t>TX</a:t>
+                        <a:t>CA</a:t>
                       </a:r>
                     </a:p>
                   </a:txBody>
@@ -24649,7 +24649,7 @@
                           </a:solidFill>
                           <a:latin typeface="Calibri"/>
                         </a:rPr>
-                        <a:t>$85,813</a:t>
+                        <a:t>$39,423</a:t>
                       </a:r>
                     </a:p>
                   </a:txBody>
@@ -24697,7 +24697,7 @@
                           </a:solidFill>
                           <a:latin typeface="Calibri"/>
                         </a:rPr>
-                        <a:t>MIGUEL ANGEL RODRIGUEZ GARCIA</a:t>
+                        <a:t>A &amp; D TRUCKING SERVICES LLC</a:t>
                       </a:r>
                     </a:p>
                   </a:txBody>
@@ -24720,7 +24720,7 @@
                           </a:solidFill>
                           <a:latin typeface="Calibri"/>
                         </a:rPr>
-                        <a:t>ECO INSURANCE SERVICES</a:t>
+                        <a:t>PR Risk Management Group Inc.</a:t>
                       </a:r>
                     </a:p>
                   </a:txBody>
@@ -24743,7 +24743,7 @@
                           </a:solidFill>
                           <a:latin typeface="Calibri"/>
                         </a:rPr>
-                        <a:t>Derrick Leroy</a:t>
+                        <a:t>—</a:t>
                       </a:r>
                     </a:p>
                   </a:txBody>
@@ -24789,7 +24789,7 @@
                           </a:solidFill>
                           <a:latin typeface="Calibri"/>
                         </a:rPr>
-                        <a:t>$11,582</a:t>
+                        <a:t>$85,813</a:t>
                       </a:r>
                     </a:p>
                   </a:txBody>
@@ -24837,7 +24837,7 @@
                           </a:solidFill>
                           <a:latin typeface="Calibri"/>
                         </a:rPr>
-                        <a:t>AJF HAULING SERVICES LLC</a:t>
+                        <a:t>MIGUEL ANGEL RODRIGUEZ GARCIA</a:t>
                       </a:r>
                     </a:p>
                   </a:txBody>
@@ -24860,7 +24860,7 @@
                           </a:solidFill>
                           <a:latin typeface="Calibri"/>
                         </a:rPr>
-                        <a:t>Eastern Underwriting Managers LLC</a:t>
+                        <a:t>ECO INSURANCE SERVICES</a:t>
                       </a:r>
                     </a:p>
                   </a:txBody>
@@ -24883,7 +24883,7 @@
                           </a:solidFill>
                           <a:latin typeface="Calibri"/>
                         </a:rPr>
-                        <a:t>—</a:t>
+                        <a:t>Derrick Leroy</a:t>
                       </a:r>
                     </a:p>
                   </a:txBody>
@@ -24929,7 +24929,7 @@
                           </a:solidFill>
                           <a:latin typeface="Calibri"/>
                         </a:rPr>
-                        <a:t>$32,489</a:t>
+                        <a:t>$11,582</a:t>
                       </a:r>
                     </a:p>
                   </a:txBody>
@@ -24954,7 +24954,7 @@
                           </a:solidFill>
                           <a:latin typeface="Calibri"/>
                         </a:rPr>
-                        <a:t>2026-05-11</a:t>
+                        <a:t>2026-05-12</a:t>
                       </a:r>
                     </a:p>
                   </a:txBody>
@@ -24977,7 +24977,7 @@
                           </a:solidFill>
                           <a:latin typeface="Calibri"/>
                         </a:rPr>
-                        <a:t>TEXAN TRUCKS AND TRAILERS LLC</a:t>
+                        <a:t>AJF HAULING SERVICES LLC</a:t>
                       </a:r>
                     </a:p>
                   </a:txBody>
@@ -25000,7 +25000,7 @@
                           </a:solidFill>
                           <a:latin typeface="Calibri"/>
                         </a:rPr>
-                        <a:t>Justin Robert Insurance Agency LLC</a:t>
+                        <a:t>Eastern Underwriting Managers LLC</a:t>
                       </a:r>
                     </a:p>
                   </a:txBody>
@@ -25023,7 +25023,7 @@
                           </a:solidFill>
                           <a:latin typeface="Calibri"/>
                         </a:rPr>
-                        <a:t>Kurt Butterfield</a:t>
+                        <a:t>—</a:t>
                       </a:r>
                     </a:p>
                   </a:txBody>
@@ -25069,7 +25069,7 @@
                           </a:solidFill>
                           <a:latin typeface="Calibri"/>
                         </a:rPr>
-                        <a:t>$34,657</a:t>
+                        <a:t>$32,489</a:t>
                       </a:r>
                     </a:p>
                   </a:txBody>
@@ -25157,7 +25157,7 @@
                 </a:solidFill>
                 <a:latin typeface="Calibri"/>
               </a:rPr>
-              <a:t>Source: Metabase Card 6472  ·  May 29, 2026</a:t>
+              <a:t>Source: Metabase Card 6472  ·  May 30, 2026</a:t>
             </a:r>
           </a:p>
         </p:txBody>

</xml_diff>

<commit_message>
Daily rebuild Sun 05/31/2026  8:22:50.39
</commit_message>
<xml_diff>
--- a/generated/DSG/DSG_May_2026_Snapshot.pptx
+++ b/generated/DSG/DSG_May_2026_Snapshot.pptx
@@ -3367,7 +3367,7 @@
                 </a:solidFill>
                 <a:latin typeface="Calibri"/>
               </a:rPr>
-              <a:t>As of May 30, 2026  |  Confidential</a:t>
+              <a:t>As of May 31, 2026  |  Confidential</a:t>
             </a:r>
           </a:p>
         </p:txBody>
@@ -3646,7 +3646,7 @@
                 </a:solidFill>
                 <a:latin typeface="Calibri"/>
               </a:rPr>
-              <a:t>166 Accounts  |  $5.14M GWP  |  May 30, 2026</a:t>
+              <a:t>166 Accounts  |  $5.14M GWP  |  May 31, 2026</a:t>
             </a:r>
           </a:p>
         </p:txBody>
@@ -3767,7 +3767,7 @@
                 </a:solidFill>
                 <a:latin typeface="Calibri Light"/>
               </a:rPr>
-              <a:t>7,527</a:t>
+              <a:t>7,530</a:t>
             </a:r>
           </a:p>
         </p:txBody>
@@ -5995,7 +5995,7 @@
                 </a:solidFill>
                 <a:latin typeface="Calibri"/>
               </a:rPr>
-              <a:t>1,573 subs · 2.3% bind</a:t>
+              <a:t>1,576 subs · 2.3% bind</a:t>
             </a:r>
           </a:p>
         </p:txBody>
@@ -6073,7 +6073,7 @@
                 </a:solidFill>
                 <a:latin typeface="Calibri"/>
               </a:rPr>
-              <a:t>Source: Metabase Cards 6472 &amp; 10306  ·  May 30, 2026</a:t>
+              <a:t>Source: Metabase Cards 6472 &amp; 10306  ·  May 31, 2026</a:t>
             </a:r>
           </a:p>
         </p:txBody>
@@ -6673,7 +6673,7 @@
                           </a:solidFill>
                           <a:latin typeface="Calibri"/>
                         </a:rPr>
-                        <a:t>James Reid</a:t>
+                        <a:t>—</a:t>
                       </a:r>
                     </a:p>
                   </a:txBody>
@@ -8269,7 +8269,7 @@
                 </a:solidFill>
                 <a:latin typeface="Calibri"/>
               </a:rPr>
-              <a:t>Source: Metabase Card 6472  ·  May 30, 2026</a:t>
+              <a:t>Source: Metabase Card 6472  ·  May 31, 2026</a:t>
             </a:r>
           </a:p>
         </p:txBody>
@@ -8706,7 +8706,7 @@
                           </a:solidFill>
                           <a:latin typeface="Calibri"/>
                         </a:rPr>
-                        <a:t>628</a:t>
+                        <a:t>629</a:t>
                       </a:r>
                     </a:p>
                   </a:txBody>
@@ -8823,145 +8823,145 @@
                           </a:solidFill>
                           <a:latin typeface="Calibri"/>
                         </a:rPr>
-                        <a:t>James Reid</a:t>
-                      </a:r>
-                    </a:p>
-                  </a:txBody>
-                  <a:tcPr anchor="ctr" marL="73152" marR="73152" marT="27432" marB="27432">
-                    <a:solidFill>
-                      <a:srgbClr val="EDE8F8"/>
-                    </a:solidFill>
-                  </a:tcPr>
-                </a:tc>
-                <a:tc>
-                  <a:txBody>
-                    <a:bodyPr/>
-                    <a:lstStyle/>
-                    <a:p>
-                      <a:pPr algn="ctr"/>
-                      <a:r>
-                        <a:rPr sz="1100" b="0">
-                          <a:solidFill>
-                            <a:srgbClr val="3A3A4A"/>
-                          </a:solidFill>
-                          <a:latin typeface="Calibri"/>
-                        </a:rPr>
-                        <a:t>6</a:t>
-                      </a:r>
-                    </a:p>
-                  </a:txBody>
-                  <a:tcPr anchor="ctr" marL="73152" marR="73152" marT="27432" marB="27432">
-                    <a:solidFill>
-                      <a:srgbClr val="EDE8F8"/>
-                    </a:solidFill>
-                  </a:tcPr>
-                </a:tc>
-                <a:tc>
-                  <a:txBody>
-                    <a:bodyPr/>
-                    <a:lstStyle/>
-                    <a:p>
-                      <a:pPr algn="ctr"/>
-                      <a:r>
-                        <a:rPr sz="1100" b="0">
-                          <a:solidFill>
-                            <a:srgbClr val="3A3A4A"/>
-                          </a:solidFill>
-                          <a:latin typeface="Calibri"/>
-                        </a:rPr>
-                        <a:t>330</a:t>
-                      </a:r>
-                    </a:p>
-                  </a:txBody>
-                  <a:tcPr anchor="ctr" marL="73152" marR="73152" marT="27432" marB="27432">
-                    <a:solidFill>
-                      <a:srgbClr val="EDE8F8"/>
-                    </a:solidFill>
-                  </a:tcPr>
-                </a:tc>
-                <a:tc>
-                  <a:txBody>
-                    <a:bodyPr/>
-                    <a:lstStyle/>
-                    <a:p>
-                      <a:pPr algn="ctr"/>
-                      <a:r>
-                        <a:rPr sz="1100" b="0">
-                          <a:solidFill>
-                            <a:srgbClr val="3A3A4A"/>
-                          </a:solidFill>
-                          <a:latin typeface="Calibri"/>
-                        </a:rPr>
-                        <a:t>160</a:t>
-                      </a:r>
-                    </a:p>
-                  </a:txBody>
-                  <a:tcPr anchor="ctr" marL="73152" marR="73152" marT="27432" marB="27432">
-                    <a:solidFill>
-                      <a:srgbClr val="EDE8F8"/>
-                    </a:solidFill>
-                  </a:tcPr>
-                </a:tc>
-                <a:tc>
-                  <a:txBody>
-                    <a:bodyPr/>
-                    <a:lstStyle/>
-                    <a:p>
-                      <a:pPr algn="ctr"/>
-                      <a:r>
-                        <a:rPr sz="1100" b="0">
-                          <a:solidFill>
-                            <a:srgbClr val="3A3A4A"/>
-                          </a:solidFill>
-                          <a:latin typeface="Calibri"/>
-                        </a:rPr>
-                        <a:t>12</a:t>
-                      </a:r>
-                    </a:p>
-                  </a:txBody>
-                  <a:tcPr anchor="ctr" marL="73152" marR="73152" marT="27432" marB="27432">
-                    <a:solidFill>
-                      <a:srgbClr val="EDE8F8"/>
-                    </a:solidFill>
-                  </a:tcPr>
-                </a:tc>
-                <a:tc>
-                  <a:txBody>
-                    <a:bodyPr/>
-                    <a:lstStyle/>
-                    <a:p>
-                      <a:pPr algn="ctr"/>
-                      <a:r>
-                        <a:rPr sz="1100" b="0">
-                          <a:solidFill>
-                            <a:srgbClr val="3A3A4A"/>
-                          </a:solidFill>
-                          <a:latin typeface="Calibri"/>
-                        </a:rPr>
-                        <a:t>3.6%</a:t>
-                      </a:r>
-                    </a:p>
-                  </a:txBody>
-                  <a:tcPr anchor="ctr" marL="73152" marR="73152" marT="27432" marB="27432">
-                    <a:solidFill>
-                      <a:srgbClr val="EDE8F8"/>
-                    </a:solidFill>
-                  </a:tcPr>
-                </a:tc>
-                <a:tc>
-                  <a:txBody>
-                    <a:bodyPr/>
-                    <a:lstStyle/>
-                    <a:p>
-                      <a:pPr algn="ctr"/>
-                      <a:r>
-                        <a:rPr sz="1100" b="0">
-                          <a:solidFill>
-                            <a:srgbClr val="3A3A4A"/>
-                          </a:solidFill>
-                          <a:latin typeface="Calibri"/>
-                        </a:rPr>
-                        <a:t>$532,870</a:t>
+                        <a:t>Derrick Leroy</a:t>
+                      </a:r>
+                    </a:p>
+                  </a:txBody>
+                  <a:tcPr anchor="ctr" marL="73152" marR="73152" marT="27432" marB="27432">
+                    <a:solidFill>
+                      <a:srgbClr val="EDE8F8"/>
+                    </a:solidFill>
+                  </a:tcPr>
+                </a:tc>
+                <a:tc>
+                  <a:txBody>
+                    <a:bodyPr/>
+                    <a:lstStyle/>
+                    <a:p>
+                      <a:pPr algn="ctr"/>
+                      <a:r>
+                        <a:rPr sz="1100" b="0">
+                          <a:solidFill>
+                            <a:srgbClr val="3A3A4A"/>
+                          </a:solidFill>
+                          <a:latin typeface="Calibri"/>
+                        </a:rPr>
+                        <a:t>23</a:t>
+                      </a:r>
+                    </a:p>
+                  </a:txBody>
+                  <a:tcPr anchor="ctr" marL="73152" marR="73152" marT="27432" marB="27432">
+                    <a:solidFill>
+                      <a:srgbClr val="EDE8F8"/>
+                    </a:solidFill>
+                  </a:tcPr>
+                </a:tc>
+                <a:tc>
+                  <a:txBody>
+                    <a:bodyPr/>
+                    <a:lstStyle/>
+                    <a:p>
+                      <a:pPr algn="ctr"/>
+                      <a:r>
+                        <a:rPr sz="1100" b="0">
+                          <a:solidFill>
+                            <a:srgbClr val="3A3A4A"/>
+                          </a:solidFill>
+                          <a:latin typeface="Calibri"/>
+                        </a:rPr>
+                        <a:t>623</a:t>
+                      </a:r>
+                    </a:p>
+                  </a:txBody>
+                  <a:tcPr anchor="ctr" marL="73152" marR="73152" marT="27432" marB="27432">
+                    <a:solidFill>
+                      <a:srgbClr val="EDE8F8"/>
+                    </a:solidFill>
+                  </a:tcPr>
+                </a:tc>
+                <a:tc>
+                  <a:txBody>
+                    <a:bodyPr/>
+                    <a:lstStyle/>
+                    <a:p>
+                      <a:pPr algn="ctr"/>
+                      <a:r>
+                        <a:rPr sz="1100" b="0">
+                          <a:solidFill>
+                            <a:srgbClr val="3A3A4A"/>
+                          </a:solidFill>
+                          <a:latin typeface="Calibri"/>
+                        </a:rPr>
+                        <a:t>254</a:t>
+                      </a:r>
+                    </a:p>
+                  </a:txBody>
+                  <a:tcPr anchor="ctr" marL="73152" marR="73152" marT="27432" marB="27432">
+                    <a:solidFill>
+                      <a:srgbClr val="EDE8F8"/>
+                    </a:solidFill>
+                  </a:tcPr>
+                </a:tc>
+                <a:tc>
+                  <a:txBody>
+                    <a:bodyPr/>
+                    <a:lstStyle/>
+                    <a:p>
+                      <a:pPr algn="ctr"/>
+                      <a:r>
+                        <a:rPr sz="1100" b="0">
+                          <a:solidFill>
+                            <a:srgbClr val="3A3A4A"/>
+                          </a:solidFill>
+                          <a:latin typeface="Calibri"/>
+                        </a:rPr>
+                        <a:t>24</a:t>
+                      </a:r>
+                    </a:p>
+                  </a:txBody>
+                  <a:tcPr anchor="ctr" marL="73152" marR="73152" marT="27432" marB="27432">
+                    <a:solidFill>
+                      <a:srgbClr val="EDE8F8"/>
+                    </a:solidFill>
+                  </a:tcPr>
+                </a:tc>
+                <a:tc>
+                  <a:txBody>
+                    <a:bodyPr/>
+                    <a:lstStyle/>
+                    <a:p>
+                      <a:pPr algn="ctr"/>
+                      <a:r>
+                        <a:rPr sz="1100" b="0">
+                          <a:solidFill>
+                            <a:srgbClr val="3A3A4A"/>
+                          </a:solidFill>
+                          <a:latin typeface="Calibri"/>
+                        </a:rPr>
+                        <a:t>3.9%</a:t>
+                      </a:r>
+                    </a:p>
+                  </a:txBody>
+                  <a:tcPr anchor="ctr" marL="73152" marR="73152" marT="27432" marB="27432">
+                    <a:solidFill>
+                      <a:srgbClr val="EDE8F8"/>
+                    </a:solidFill>
+                  </a:tcPr>
+                </a:tc>
+                <a:tc>
+                  <a:txBody>
+                    <a:bodyPr/>
+                    <a:lstStyle/>
+                    <a:p>
+                      <a:pPr algn="ctr"/>
+                      <a:r>
+                        <a:rPr sz="1100" b="0">
+                          <a:solidFill>
+                            <a:srgbClr val="3A3A4A"/>
+                          </a:solidFill>
+                          <a:latin typeface="Calibri"/>
+                        </a:rPr>
+                        <a:t>$532,605</a:t>
                       </a:r>
                     </a:p>
                   </a:txBody>
@@ -8986,145 +8986,145 @@
                           </a:solidFill>
                           <a:latin typeface="Calibri"/>
                         </a:rPr>
-                        <a:t>Derrick Leroy</a:t>
-                      </a:r>
-                    </a:p>
-                  </a:txBody>
-                  <a:tcPr anchor="ctr" marL="73152" marR="73152" marT="27432" marB="27432">
-                    <a:solidFill>
-                      <a:srgbClr val="F5F0FC"/>
-                    </a:solidFill>
-                  </a:tcPr>
-                </a:tc>
-                <a:tc>
-                  <a:txBody>
-                    <a:bodyPr/>
-                    <a:lstStyle/>
-                    <a:p>
-                      <a:pPr algn="ctr"/>
-                      <a:r>
-                        <a:rPr sz="1100" b="0">
-                          <a:solidFill>
-                            <a:srgbClr val="3A3A4A"/>
-                          </a:solidFill>
-                          <a:latin typeface="Calibri"/>
-                        </a:rPr>
-                        <a:t>23</a:t>
-                      </a:r>
-                    </a:p>
-                  </a:txBody>
-                  <a:tcPr anchor="ctr" marL="73152" marR="73152" marT="27432" marB="27432">
-                    <a:solidFill>
-                      <a:srgbClr val="F5F0FC"/>
-                    </a:solidFill>
-                  </a:tcPr>
-                </a:tc>
-                <a:tc>
-                  <a:txBody>
-                    <a:bodyPr/>
-                    <a:lstStyle/>
-                    <a:p>
-                      <a:pPr algn="ctr"/>
-                      <a:r>
-                        <a:rPr sz="1100" b="0">
-                          <a:solidFill>
-                            <a:srgbClr val="3A3A4A"/>
-                          </a:solidFill>
-                          <a:latin typeface="Calibri"/>
-                        </a:rPr>
-                        <a:t>623</a:t>
-                      </a:r>
-                    </a:p>
-                  </a:txBody>
-                  <a:tcPr anchor="ctr" marL="73152" marR="73152" marT="27432" marB="27432">
-                    <a:solidFill>
-                      <a:srgbClr val="F5F0FC"/>
-                    </a:solidFill>
-                  </a:tcPr>
-                </a:tc>
-                <a:tc>
-                  <a:txBody>
-                    <a:bodyPr/>
-                    <a:lstStyle/>
-                    <a:p>
-                      <a:pPr algn="ctr"/>
-                      <a:r>
-                        <a:rPr sz="1100" b="0">
-                          <a:solidFill>
-                            <a:srgbClr val="3A3A4A"/>
-                          </a:solidFill>
-                          <a:latin typeface="Calibri"/>
-                        </a:rPr>
-                        <a:t>254</a:t>
-                      </a:r>
-                    </a:p>
-                  </a:txBody>
-                  <a:tcPr anchor="ctr" marL="73152" marR="73152" marT="27432" marB="27432">
-                    <a:solidFill>
-                      <a:srgbClr val="F5F0FC"/>
-                    </a:solidFill>
-                  </a:tcPr>
-                </a:tc>
-                <a:tc>
-                  <a:txBody>
-                    <a:bodyPr/>
-                    <a:lstStyle/>
-                    <a:p>
-                      <a:pPr algn="ctr"/>
-                      <a:r>
-                        <a:rPr sz="1100" b="0">
-                          <a:solidFill>
-                            <a:srgbClr val="3A3A4A"/>
-                          </a:solidFill>
-                          <a:latin typeface="Calibri"/>
-                        </a:rPr>
-                        <a:t>24</a:t>
-                      </a:r>
-                    </a:p>
-                  </a:txBody>
-                  <a:tcPr anchor="ctr" marL="73152" marR="73152" marT="27432" marB="27432">
-                    <a:solidFill>
-                      <a:srgbClr val="F5F0FC"/>
-                    </a:solidFill>
-                  </a:tcPr>
-                </a:tc>
-                <a:tc>
-                  <a:txBody>
-                    <a:bodyPr/>
-                    <a:lstStyle/>
-                    <a:p>
-                      <a:pPr algn="ctr"/>
-                      <a:r>
-                        <a:rPr sz="1100" b="0">
-                          <a:solidFill>
-                            <a:srgbClr val="3A3A4A"/>
-                          </a:solidFill>
-                          <a:latin typeface="Calibri"/>
-                        </a:rPr>
-                        <a:t>3.9%</a:t>
-                      </a:r>
-                    </a:p>
-                  </a:txBody>
-                  <a:tcPr anchor="ctr" marL="73152" marR="73152" marT="27432" marB="27432">
-                    <a:solidFill>
-                      <a:srgbClr val="F5F0FC"/>
-                    </a:solidFill>
-                  </a:tcPr>
-                </a:tc>
-                <a:tc>
-                  <a:txBody>
-                    <a:bodyPr/>
-                    <a:lstStyle/>
-                    <a:p>
-                      <a:pPr algn="ctr"/>
-                      <a:r>
-                        <a:rPr sz="1100" b="0">
-                          <a:solidFill>
-                            <a:srgbClr val="3A3A4A"/>
-                          </a:solidFill>
-                          <a:latin typeface="Calibri"/>
-                        </a:rPr>
-                        <a:t>$532,605</a:t>
+                        <a:t>Kurt Butterfield</a:t>
+                      </a:r>
+                    </a:p>
+                  </a:txBody>
+                  <a:tcPr anchor="ctr" marL="73152" marR="73152" marT="27432" marB="27432">
+                    <a:solidFill>
+                      <a:srgbClr val="F5F0FC"/>
+                    </a:solidFill>
+                  </a:tcPr>
+                </a:tc>
+                <a:tc>
+                  <a:txBody>
+                    <a:bodyPr/>
+                    <a:lstStyle/>
+                    <a:p>
+                      <a:pPr algn="ctr"/>
+                      <a:r>
+                        <a:rPr sz="1100" b="0">
+                          <a:solidFill>
+                            <a:srgbClr val="3A3A4A"/>
+                          </a:solidFill>
+                          <a:latin typeface="Calibri"/>
+                        </a:rPr>
+                        <a:t>30</a:t>
+                      </a:r>
+                    </a:p>
+                  </a:txBody>
+                  <a:tcPr anchor="ctr" marL="73152" marR="73152" marT="27432" marB="27432">
+                    <a:solidFill>
+                      <a:srgbClr val="F5F0FC"/>
+                    </a:solidFill>
+                  </a:tcPr>
+                </a:tc>
+                <a:tc>
+                  <a:txBody>
+                    <a:bodyPr/>
+                    <a:lstStyle/>
+                    <a:p>
+                      <a:pPr algn="ctr"/>
+                      <a:r>
+                        <a:rPr sz="1100" b="0">
+                          <a:solidFill>
+                            <a:srgbClr val="3A3A4A"/>
+                          </a:solidFill>
+                          <a:latin typeface="Calibri"/>
+                        </a:rPr>
+                        <a:t>1052</a:t>
+                      </a:r>
+                    </a:p>
+                  </a:txBody>
+                  <a:tcPr anchor="ctr" marL="73152" marR="73152" marT="27432" marB="27432">
+                    <a:solidFill>
+                      <a:srgbClr val="F5F0FC"/>
+                    </a:solidFill>
+                  </a:tcPr>
+                </a:tc>
+                <a:tc>
+                  <a:txBody>
+                    <a:bodyPr/>
+                    <a:lstStyle/>
+                    <a:p>
+                      <a:pPr algn="ctr"/>
+                      <a:r>
+                        <a:rPr sz="1100" b="0">
+                          <a:solidFill>
+                            <a:srgbClr val="3A3A4A"/>
+                          </a:solidFill>
+                          <a:latin typeface="Calibri"/>
+                        </a:rPr>
+                        <a:t>391</a:t>
+                      </a:r>
+                    </a:p>
+                  </a:txBody>
+                  <a:tcPr anchor="ctr" marL="73152" marR="73152" marT="27432" marB="27432">
+                    <a:solidFill>
+                      <a:srgbClr val="F5F0FC"/>
+                    </a:solidFill>
+                  </a:tcPr>
+                </a:tc>
+                <a:tc>
+                  <a:txBody>
+                    <a:bodyPr/>
+                    <a:lstStyle/>
+                    <a:p>
+                      <a:pPr algn="ctr"/>
+                      <a:r>
+                        <a:rPr sz="1100" b="0">
+                          <a:solidFill>
+                            <a:srgbClr val="3A3A4A"/>
+                          </a:solidFill>
+                          <a:latin typeface="Calibri"/>
+                        </a:rPr>
+                        <a:t>14</a:t>
+                      </a:r>
+                    </a:p>
+                  </a:txBody>
+                  <a:tcPr anchor="ctr" marL="73152" marR="73152" marT="27432" marB="27432">
+                    <a:solidFill>
+                      <a:srgbClr val="F5F0FC"/>
+                    </a:solidFill>
+                  </a:tcPr>
+                </a:tc>
+                <a:tc>
+                  <a:txBody>
+                    <a:bodyPr/>
+                    <a:lstStyle/>
+                    <a:p>
+                      <a:pPr algn="ctr"/>
+                      <a:r>
+                        <a:rPr sz="1100" b="0">
+                          <a:solidFill>
+                            <a:srgbClr val="3A3A4A"/>
+                          </a:solidFill>
+                          <a:latin typeface="Calibri"/>
+                        </a:rPr>
+                        <a:t>1.3%</a:t>
+                      </a:r>
+                    </a:p>
+                  </a:txBody>
+                  <a:tcPr anchor="ctr" marL="73152" marR="73152" marT="27432" marB="27432">
+                    <a:solidFill>
+                      <a:srgbClr val="F5F0FC"/>
+                    </a:solidFill>
+                  </a:tcPr>
+                </a:tc>
+                <a:tc>
+                  <a:txBody>
+                    <a:bodyPr/>
+                    <a:lstStyle/>
+                    <a:p>
+                      <a:pPr algn="ctr"/>
+                      <a:r>
+                        <a:rPr sz="1100" b="0">
+                          <a:solidFill>
+                            <a:srgbClr val="3A3A4A"/>
+                          </a:solidFill>
+                          <a:latin typeface="Calibri"/>
+                        </a:rPr>
+                        <a:t>$408,533</a:t>
                       </a:r>
                     </a:p>
                   </a:txBody>
@@ -9149,145 +9149,145 @@
                           </a:solidFill>
                           <a:latin typeface="Calibri"/>
                         </a:rPr>
-                        <a:t>Kurt Butterfield</a:t>
-                      </a:r>
-                    </a:p>
-                  </a:txBody>
-                  <a:tcPr anchor="ctr" marL="73152" marR="73152" marT="27432" marB="27432">
-                    <a:solidFill>
-                      <a:srgbClr val="EDE8F8"/>
-                    </a:solidFill>
-                  </a:tcPr>
-                </a:tc>
-                <a:tc>
-                  <a:txBody>
-                    <a:bodyPr/>
-                    <a:lstStyle/>
-                    <a:p>
-                      <a:pPr algn="ctr"/>
-                      <a:r>
-                        <a:rPr sz="1100" b="0">
-                          <a:solidFill>
-                            <a:srgbClr val="3A3A4A"/>
-                          </a:solidFill>
-                          <a:latin typeface="Calibri"/>
-                        </a:rPr>
-                        <a:t>30</a:t>
-                      </a:r>
-                    </a:p>
-                  </a:txBody>
-                  <a:tcPr anchor="ctr" marL="73152" marR="73152" marT="27432" marB="27432">
-                    <a:solidFill>
-                      <a:srgbClr val="EDE8F8"/>
-                    </a:solidFill>
-                  </a:tcPr>
-                </a:tc>
-                <a:tc>
-                  <a:txBody>
-                    <a:bodyPr/>
-                    <a:lstStyle/>
-                    <a:p>
-                      <a:pPr algn="ctr"/>
-                      <a:r>
-                        <a:rPr sz="1100" b="0">
-                          <a:solidFill>
-                            <a:srgbClr val="3A3A4A"/>
-                          </a:solidFill>
-                          <a:latin typeface="Calibri"/>
-                        </a:rPr>
-                        <a:t>1051</a:t>
-                      </a:r>
-                    </a:p>
-                  </a:txBody>
-                  <a:tcPr anchor="ctr" marL="73152" marR="73152" marT="27432" marB="27432">
-                    <a:solidFill>
-                      <a:srgbClr val="EDE8F8"/>
-                    </a:solidFill>
-                  </a:tcPr>
-                </a:tc>
-                <a:tc>
-                  <a:txBody>
-                    <a:bodyPr/>
-                    <a:lstStyle/>
-                    <a:p>
-                      <a:pPr algn="ctr"/>
-                      <a:r>
-                        <a:rPr sz="1100" b="0">
-                          <a:solidFill>
-                            <a:srgbClr val="3A3A4A"/>
-                          </a:solidFill>
-                          <a:latin typeface="Calibri"/>
-                        </a:rPr>
-                        <a:t>390</a:t>
-                      </a:r>
-                    </a:p>
-                  </a:txBody>
-                  <a:tcPr anchor="ctr" marL="73152" marR="73152" marT="27432" marB="27432">
-                    <a:solidFill>
-                      <a:srgbClr val="EDE8F8"/>
-                    </a:solidFill>
-                  </a:tcPr>
-                </a:tc>
-                <a:tc>
-                  <a:txBody>
-                    <a:bodyPr/>
-                    <a:lstStyle/>
-                    <a:p>
-                      <a:pPr algn="ctr"/>
-                      <a:r>
-                        <a:rPr sz="1100" b="0">
-                          <a:solidFill>
-                            <a:srgbClr val="3A3A4A"/>
-                          </a:solidFill>
-                          <a:latin typeface="Calibri"/>
-                        </a:rPr>
-                        <a:t>14</a:t>
-                      </a:r>
-                    </a:p>
-                  </a:txBody>
-                  <a:tcPr anchor="ctr" marL="73152" marR="73152" marT="27432" marB="27432">
-                    <a:solidFill>
-                      <a:srgbClr val="EDE8F8"/>
-                    </a:solidFill>
-                  </a:tcPr>
-                </a:tc>
-                <a:tc>
-                  <a:txBody>
-                    <a:bodyPr/>
-                    <a:lstStyle/>
-                    <a:p>
-                      <a:pPr algn="ctr"/>
-                      <a:r>
-                        <a:rPr sz="1100" b="0">
-                          <a:solidFill>
-                            <a:srgbClr val="3A3A4A"/>
-                          </a:solidFill>
-                          <a:latin typeface="Calibri"/>
-                        </a:rPr>
-                        <a:t>1.3%</a:t>
-                      </a:r>
-                    </a:p>
-                  </a:txBody>
-                  <a:tcPr anchor="ctr" marL="73152" marR="73152" marT="27432" marB="27432">
-                    <a:solidFill>
-                      <a:srgbClr val="EDE8F8"/>
-                    </a:solidFill>
-                  </a:tcPr>
-                </a:tc>
-                <a:tc>
-                  <a:txBody>
-                    <a:bodyPr/>
-                    <a:lstStyle/>
-                    <a:p>
-                      <a:pPr algn="ctr"/>
-                      <a:r>
-                        <a:rPr sz="1100" b="0">
-                          <a:solidFill>
-                            <a:srgbClr val="3A3A4A"/>
-                          </a:solidFill>
-                          <a:latin typeface="Calibri"/>
-                        </a:rPr>
-                        <a:t>$408,533</a:t>
+                        <a:t>Ron Douglas</a:t>
+                      </a:r>
+                    </a:p>
+                  </a:txBody>
+                  <a:tcPr anchor="ctr" marL="73152" marR="73152" marT="27432" marB="27432">
+                    <a:solidFill>
+                      <a:srgbClr val="EDE8F8"/>
+                    </a:solidFill>
+                  </a:tcPr>
+                </a:tc>
+                <a:tc>
+                  <a:txBody>
+                    <a:bodyPr/>
+                    <a:lstStyle/>
+                    <a:p>
+                      <a:pPr algn="ctr"/>
+                      <a:r>
+                        <a:rPr sz="1100" b="0">
+                          <a:solidFill>
+                            <a:srgbClr val="3A3A4A"/>
+                          </a:solidFill>
+                          <a:latin typeface="Calibri"/>
+                        </a:rPr>
+                        <a:t>23</a:t>
+                      </a:r>
+                    </a:p>
+                  </a:txBody>
+                  <a:tcPr anchor="ctr" marL="73152" marR="73152" marT="27432" marB="27432">
+                    <a:solidFill>
+                      <a:srgbClr val="EDE8F8"/>
+                    </a:solidFill>
+                  </a:tcPr>
+                </a:tc>
+                <a:tc>
+                  <a:txBody>
+                    <a:bodyPr/>
+                    <a:lstStyle/>
+                    <a:p>
+                      <a:pPr algn="ctr"/>
+                      <a:r>
+                        <a:rPr sz="1100" b="0">
+                          <a:solidFill>
+                            <a:srgbClr val="3A3A4A"/>
+                          </a:solidFill>
+                          <a:latin typeface="Calibri"/>
+                        </a:rPr>
+                        <a:t>448</a:t>
+                      </a:r>
+                    </a:p>
+                  </a:txBody>
+                  <a:tcPr anchor="ctr" marL="73152" marR="73152" marT="27432" marB="27432">
+                    <a:solidFill>
+                      <a:srgbClr val="EDE8F8"/>
+                    </a:solidFill>
+                  </a:tcPr>
+                </a:tc>
+                <a:tc>
+                  <a:txBody>
+                    <a:bodyPr/>
+                    <a:lstStyle/>
+                    <a:p>
+                      <a:pPr algn="ctr"/>
+                      <a:r>
+                        <a:rPr sz="1100" b="0">
+                          <a:solidFill>
+                            <a:srgbClr val="3A3A4A"/>
+                          </a:solidFill>
+                          <a:latin typeface="Calibri"/>
+                        </a:rPr>
+                        <a:t>216</a:t>
+                      </a:r>
+                    </a:p>
+                  </a:txBody>
+                  <a:tcPr anchor="ctr" marL="73152" marR="73152" marT="27432" marB="27432">
+                    <a:solidFill>
+                      <a:srgbClr val="EDE8F8"/>
+                    </a:solidFill>
+                  </a:tcPr>
+                </a:tc>
+                <a:tc>
+                  <a:txBody>
+                    <a:bodyPr/>
+                    <a:lstStyle/>
+                    <a:p>
+                      <a:pPr algn="ctr"/>
+                      <a:r>
+                        <a:rPr sz="1100" b="0">
+                          <a:solidFill>
+                            <a:srgbClr val="3A3A4A"/>
+                          </a:solidFill>
+                          <a:latin typeface="Calibri"/>
+                        </a:rPr>
+                        <a:t>16</a:t>
+                      </a:r>
+                    </a:p>
+                  </a:txBody>
+                  <a:tcPr anchor="ctr" marL="73152" marR="73152" marT="27432" marB="27432">
+                    <a:solidFill>
+                      <a:srgbClr val="EDE8F8"/>
+                    </a:solidFill>
+                  </a:tcPr>
+                </a:tc>
+                <a:tc>
+                  <a:txBody>
+                    <a:bodyPr/>
+                    <a:lstStyle/>
+                    <a:p>
+                      <a:pPr algn="ctr"/>
+                      <a:r>
+                        <a:rPr sz="1100" b="0">
+                          <a:solidFill>
+                            <a:srgbClr val="3A3A4A"/>
+                          </a:solidFill>
+                          <a:latin typeface="Calibri"/>
+                        </a:rPr>
+                        <a:t>3.6%</a:t>
+                      </a:r>
+                    </a:p>
+                  </a:txBody>
+                  <a:tcPr anchor="ctr" marL="73152" marR="73152" marT="27432" marB="27432">
+                    <a:solidFill>
+                      <a:srgbClr val="EDE8F8"/>
+                    </a:solidFill>
+                  </a:tcPr>
+                </a:tc>
+                <a:tc>
+                  <a:txBody>
+                    <a:bodyPr/>
+                    <a:lstStyle/>
+                    <a:p>
+                      <a:pPr algn="ctr"/>
+                      <a:r>
+                        <a:rPr sz="1100" b="0">
+                          <a:solidFill>
+                            <a:srgbClr val="3A3A4A"/>
+                          </a:solidFill>
+                          <a:latin typeface="Calibri"/>
+                        </a:rPr>
+                        <a:t>$299,457</a:t>
                       </a:r>
                     </a:p>
                   </a:txBody>
@@ -9312,145 +9312,145 @@
                           </a:solidFill>
                           <a:latin typeface="Calibri"/>
                         </a:rPr>
-                        <a:t>Ron Douglas</a:t>
-                      </a:r>
-                    </a:p>
-                  </a:txBody>
-                  <a:tcPr anchor="ctr" marL="73152" marR="73152" marT="27432" marB="27432">
-                    <a:solidFill>
-                      <a:srgbClr val="F5F0FC"/>
-                    </a:solidFill>
-                  </a:tcPr>
-                </a:tc>
-                <a:tc>
-                  <a:txBody>
-                    <a:bodyPr/>
-                    <a:lstStyle/>
-                    <a:p>
-                      <a:pPr algn="ctr"/>
-                      <a:r>
-                        <a:rPr sz="1100" b="0">
-                          <a:solidFill>
-                            <a:srgbClr val="3A3A4A"/>
-                          </a:solidFill>
-                          <a:latin typeface="Calibri"/>
-                        </a:rPr>
-                        <a:t>23</a:t>
-                      </a:r>
-                    </a:p>
-                  </a:txBody>
-                  <a:tcPr anchor="ctr" marL="73152" marR="73152" marT="27432" marB="27432">
-                    <a:solidFill>
-                      <a:srgbClr val="F5F0FC"/>
-                    </a:solidFill>
-                  </a:tcPr>
-                </a:tc>
-                <a:tc>
-                  <a:txBody>
-                    <a:bodyPr/>
-                    <a:lstStyle/>
-                    <a:p>
-                      <a:pPr algn="ctr"/>
-                      <a:r>
-                        <a:rPr sz="1100" b="0">
-                          <a:solidFill>
-                            <a:srgbClr val="3A3A4A"/>
-                          </a:solidFill>
-                          <a:latin typeface="Calibri"/>
-                        </a:rPr>
-                        <a:t>447</a:t>
-                      </a:r>
-                    </a:p>
-                  </a:txBody>
-                  <a:tcPr anchor="ctr" marL="73152" marR="73152" marT="27432" marB="27432">
-                    <a:solidFill>
-                      <a:srgbClr val="F5F0FC"/>
-                    </a:solidFill>
-                  </a:tcPr>
-                </a:tc>
-                <a:tc>
-                  <a:txBody>
-                    <a:bodyPr/>
-                    <a:lstStyle/>
-                    <a:p>
-                      <a:pPr algn="ctr"/>
-                      <a:r>
-                        <a:rPr sz="1100" b="0">
-                          <a:solidFill>
-                            <a:srgbClr val="3A3A4A"/>
-                          </a:solidFill>
-                          <a:latin typeface="Calibri"/>
-                        </a:rPr>
-                        <a:t>215</a:t>
-                      </a:r>
-                    </a:p>
-                  </a:txBody>
-                  <a:tcPr anchor="ctr" marL="73152" marR="73152" marT="27432" marB="27432">
-                    <a:solidFill>
-                      <a:srgbClr val="F5F0FC"/>
-                    </a:solidFill>
-                  </a:tcPr>
-                </a:tc>
-                <a:tc>
-                  <a:txBody>
-                    <a:bodyPr/>
-                    <a:lstStyle/>
-                    <a:p>
-                      <a:pPr algn="ctr"/>
-                      <a:r>
-                        <a:rPr sz="1100" b="0">
-                          <a:solidFill>
-                            <a:srgbClr val="3A3A4A"/>
-                          </a:solidFill>
-                          <a:latin typeface="Calibri"/>
-                        </a:rPr>
-                        <a:t>16</a:t>
-                      </a:r>
-                    </a:p>
-                  </a:txBody>
-                  <a:tcPr anchor="ctr" marL="73152" marR="73152" marT="27432" marB="27432">
-                    <a:solidFill>
-                      <a:srgbClr val="F5F0FC"/>
-                    </a:solidFill>
-                  </a:tcPr>
-                </a:tc>
-                <a:tc>
-                  <a:txBody>
-                    <a:bodyPr/>
-                    <a:lstStyle/>
-                    <a:p>
-                      <a:pPr algn="ctr"/>
-                      <a:r>
-                        <a:rPr sz="1100" b="0">
-                          <a:solidFill>
-                            <a:srgbClr val="3A3A4A"/>
-                          </a:solidFill>
-                          <a:latin typeface="Calibri"/>
-                        </a:rPr>
-                        <a:t>3.6%</a:t>
-                      </a:r>
-                    </a:p>
-                  </a:txBody>
-                  <a:tcPr anchor="ctr" marL="73152" marR="73152" marT="27432" marB="27432">
-                    <a:solidFill>
-                      <a:srgbClr val="F5F0FC"/>
-                    </a:solidFill>
-                  </a:tcPr>
-                </a:tc>
-                <a:tc>
-                  <a:txBody>
-                    <a:bodyPr/>
-                    <a:lstStyle/>
-                    <a:p>
-                      <a:pPr algn="ctr"/>
-                      <a:r>
-                        <a:rPr sz="1100" b="0">
-                          <a:solidFill>
-                            <a:srgbClr val="3A3A4A"/>
-                          </a:solidFill>
-                          <a:latin typeface="Calibri"/>
-                        </a:rPr>
-                        <a:t>$299,457</a:t>
+                        <a:t>James Reid</a:t>
+                      </a:r>
+                    </a:p>
+                  </a:txBody>
+                  <a:tcPr anchor="ctr" marL="73152" marR="73152" marT="27432" marB="27432">
+                    <a:solidFill>
+                      <a:srgbClr val="F5F0FC"/>
+                    </a:solidFill>
+                  </a:tcPr>
+                </a:tc>
+                <a:tc>
+                  <a:txBody>
+                    <a:bodyPr/>
+                    <a:lstStyle/>
+                    <a:p>
+                      <a:pPr algn="ctr"/>
+                      <a:r>
+                        <a:rPr sz="1100" b="0">
+                          <a:solidFill>
+                            <a:srgbClr val="3A3A4A"/>
+                          </a:solidFill>
+                          <a:latin typeface="Calibri"/>
+                        </a:rPr>
+                        <a:t>5</a:t>
+                      </a:r>
+                    </a:p>
+                  </a:txBody>
+                  <a:tcPr anchor="ctr" marL="73152" marR="73152" marT="27432" marB="27432">
+                    <a:solidFill>
+                      <a:srgbClr val="F5F0FC"/>
+                    </a:solidFill>
+                  </a:tcPr>
+                </a:tc>
+                <a:tc>
+                  <a:txBody>
+                    <a:bodyPr/>
+                    <a:lstStyle/>
+                    <a:p>
+                      <a:pPr algn="ctr"/>
+                      <a:r>
+                        <a:rPr sz="1100" b="0">
+                          <a:solidFill>
+                            <a:srgbClr val="3A3A4A"/>
+                          </a:solidFill>
+                          <a:latin typeface="Calibri"/>
+                        </a:rPr>
+                        <a:t>89</a:t>
+                      </a:r>
+                    </a:p>
+                  </a:txBody>
+                  <a:tcPr anchor="ctr" marL="73152" marR="73152" marT="27432" marB="27432">
+                    <a:solidFill>
+                      <a:srgbClr val="F5F0FC"/>
+                    </a:solidFill>
+                  </a:tcPr>
+                </a:tc>
+                <a:tc>
+                  <a:txBody>
+                    <a:bodyPr/>
+                    <a:lstStyle/>
+                    <a:p>
+                      <a:pPr algn="ctr"/>
+                      <a:r>
+                        <a:rPr sz="1100" b="0">
+                          <a:solidFill>
+                            <a:srgbClr val="3A3A4A"/>
+                          </a:solidFill>
+                          <a:latin typeface="Calibri"/>
+                        </a:rPr>
+                        <a:t>32</a:t>
+                      </a:r>
+                    </a:p>
+                  </a:txBody>
+                  <a:tcPr anchor="ctr" marL="73152" marR="73152" marT="27432" marB="27432">
+                    <a:solidFill>
+                      <a:srgbClr val="F5F0FC"/>
+                    </a:solidFill>
+                  </a:tcPr>
+                </a:tc>
+                <a:tc>
+                  <a:txBody>
+                    <a:bodyPr/>
+                    <a:lstStyle/>
+                    <a:p>
+                      <a:pPr algn="ctr"/>
+                      <a:r>
+                        <a:rPr sz="1100" b="0">
+                          <a:solidFill>
+                            <a:srgbClr val="3A3A4A"/>
+                          </a:solidFill>
+                          <a:latin typeface="Calibri"/>
+                        </a:rPr>
+                        <a:t>6</a:t>
+                      </a:r>
+                    </a:p>
+                  </a:txBody>
+                  <a:tcPr anchor="ctr" marL="73152" marR="73152" marT="27432" marB="27432">
+                    <a:solidFill>
+                      <a:srgbClr val="F5F0FC"/>
+                    </a:solidFill>
+                  </a:tcPr>
+                </a:tc>
+                <a:tc>
+                  <a:txBody>
+                    <a:bodyPr/>
+                    <a:lstStyle/>
+                    <a:p>
+                      <a:pPr algn="ctr"/>
+                      <a:r>
+                        <a:rPr sz="1100" b="0">
+                          <a:solidFill>
+                            <a:srgbClr val="3A3A4A"/>
+                          </a:solidFill>
+                          <a:latin typeface="Calibri"/>
+                        </a:rPr>
+                        <a:t>6.7%</a:t>
+                      </a:r>
+                    </a:p>
+                  </a:txBody>
+                  <a:tcPr anchor="ctr" marL="73152" marR="73152" marT="27432" marB="27432">
+                    <a:solidFill>
+                      <a:srgbClr val="F5F0FC"/>
+                    </a:solidFill>
+                  </a:tcPr>
+                </a:tc>
+                <a:tc>
+                  <a:txBody>
+                    <a:bodyPr/>
+                    <a:lstStyle/>
+                    <a:p>
+                      <a:pPr algn="ctr"/>
+                      <a:r>
+                        <a:rPr sz="1100" b="0">
+                          <a:solidFill>
+                            <a:srgbClr val="3A3A4A"/>
+                          </a:solidFill>
+                          <a:latin typeface="Calibri"/>
+                        </a:rPr>
+                        <a:t>$258,021</a:t>
                       </a:r>
                     </a:p>
                   </a:txBody>
@@ -10965,122 +10965,122 @@
                           </a:solidFill>
                           <a:latin typeface="Calibri"/>
                         </a:rPr>
-                        <a:t>236</a:t>
-                      </a:r>
-                    </a:p>
-                  </a:txBody>
-                  <a:tcPr anchor="ctr" marL="73152" marR="73152" marT="27432" marB="27432">
-                    <a:solidFill>
-                      <a:srgbClr val="F5F0FC"/>
-                    </a:solidFill>
-                  </a:tcPr>
-                </a:tc>
-                <a:tc>
-                  <a:txBody>
-                    <a:bodyPr/>
-                    <a:lstStyle/>
-                    <a:p>
-                      <a:pPr algn="ctr"/>
-                      <a:r>
-                        <a:rPr sz="1100" b="0">
-                          <a:solidFill>
-                            <a:srgbClr val="3A3A4A"/>
-                          </a:solidFill>
-                          <a:latin typeface="Calibri"/>
-                        </a:rPr>
-                        <a:t>2812</a:t>
-                      </a:r>
-                    </a:p>
-                  </a:txBody>
-                  <a:tcPr anchor="ctr" marL="73152" marR="73152" marT="27432" marB="27432">
-                    <a:solidFill>
-                      <a:srgbClr val="F5F0FC"/>
-                    </a:solidFill>
-                  </a:tcPr>
-                </a:tc>
-                <a:tc>
-                  <a:txBody>
-                    <a:bodyPr/>
-                    <a:lstStyle/>
-                    <a:p>
-                      <a:pPr algn="ctr"/>
-                      <a:r>
-                        <a:rPr sz="1100" b="0">
-                          <a:solidFill>
-                            <a:srgbClr val="3A3A4A"/>
-                          </a:solidFill>
-                          <a:latin typeface="Calibri"/>
-                        </a:rPr>
-                        <a:t>1192</a:t>
-                      </a:r>
-                    </a:p>
-                  </a:txBody>
-                  <a:tcPr anchor="ctr" marL="73152" marR="73152" marT="27432" marB="27432">
-                    <a:solidFill>
-                      <a:srgbClr val="F5F0FC"/>
-                    </a:solidFill>
-                  </a:tcPr>
-                </a:tc>
-                <a:tc>
-                  <a:txBody>
-                    <a:bodyPr/>
-                    <a:lstStyle/>
-                    <a:p>
-                      <a:pPr algn="ctr"/>
-                      <a:r>
-                        <a:rPr sz="1100" b="0">
-                          <a:solidFill>
-                            <a:srgbClr val="3A3A4A"/>
-                          </a:solidFill>
-                          <a:latin typeface="Calibri"/>
-                        </a:rPr>
-                        <a:t>31</a:t>
-                      </a:r>
-                    </a:p>
-                  </a:txBody>
-                  <a:tcPr anchor="ctr" marL="73152" marR="73152" marT="27432" marB="27432">
-                    <a:solidFill>
-                      <a:srgbClr val="F5F0FC"/>
-                    </a:solidFill>
-                  </a:tcPr>
-                </a:tc>
-                <a:tc>
-                  <a:txBody>
-                    <a:bodyPr/>
-                    <a:lstStyle/>
-                    <a:p>
-                      <a:pPr algn="ctr"/>
-                      <a:r>
-                        <a:rPr sz="1100" b="0">
-                          <a:solidFill>
-                            <a:srgbClr val="3A3A4A"/>
-                          </a:solidFill>
-                          <a:latin typeface="Calibri"/>
-                        </a:rPr>
-                        <a:t>1.1%</a:t>
-                      </a:r>
-                    </a:p>
-                  </a:txBody>
-                  <a:tcPr anchor="ctr" marL="73152" marR="73152" marT="27432" marB="27432">
-                    <a:solidFill>
-                      <a:srgbClr val="F5F0FC"/>
-                    </a:solidFill>
-                  </a:tcPr>
-                </a:tc>
-                <a:tc>
-                  <a:txBody>
-                    <a:bodyPr/>
-                    <a:lstStyle/>
-                    <a:p>
-                      <a:pPr algn="ctr"/>
-                      <a:r>
-                        <a:rPr sz="1100" b="0">
-                          <a:solidFill>
-                            <a:srgbClr val="3A3A4A"/>
-                          </a:solidFill>
-                          <a:latin typeface="Calibri"/>
-                        </a:rPr>
-                        <a:t>$1,110,326</a:t>
+                        <a:t>237</a:t>
+                      </a:r>
+                    </a:p>
+                  </a:txBody>
+                  <a:tcPr anchor="ctr" marL="73152" marR="73152" marT="27432" marB="27432">
+                    <a:solidFill>
+                      <a:srgbClr val="F5F0FC"/>
+                    </a:solidFill>
+                  </a:tcPr>
+                </a:tc>
+                <a:tc>
+                  <a:txBody>
+                    <a:bodyPr/>
+                    <a:lstStyle/>
+                    <a:p>
+                      <a:pPr algn="ctr"/>
+                      <a:r>
+                        <a:rPr sz="1100" b="0">
+                          <a:solidFill>
+                            <a:srgbClr val="3A3A4A"/>
+                          </a:solidFill>
+                          <a:latin typeface="Calibri"/>
+                        </a:rPr>
+                        <a:t>3053</a:t>
+                      </a:r>
+                    </a:p>
+                  </a:txBody>
+                  <a:tcPr anchor="ctr" marL="73152" marR="73152" marT="27432" marB="27432">
+                    <a:solidFill>
+                      <a:srgbClr val="F5F0FC"/>
+                    </a:solidFill>
+                  </a:tcPr>
+                </a:tc>
+                <a:tc>
+                  <a:txBody>
+                    <a:bodyPr/>
+                    <a:lstStyle/>
+                    <a:p>
+                      <a:pPr algn="ctr"/>
+                      <a:r>
+                        <a:rPr sz="1100" b="0">
+                          <a:solidFill>
+                            <a:srgbClr val="3A3A4A"/>
+                          </a:solidFill>
+                          <a:latin typeface="Calibri"/>
+                        </a:rPr>
+                        <a:t>1320</a:t>
+                      </a:r>
+                    </a:p>
+                  </a:txBody>
+                  <a:tcPr anchor="ctr" marL="73152" marR="73152" marT="27432" marB="27432">
+                    <a:solidFill>
+                      <a:srgbClr val="F5F0FC"/>
+                    </a:solidFill>
+                  </a:tcPr>
+                </a:tc>
+                <a:tc>
+                  <a:txBody>
+                    <a:bodyPr/>
+                    <a:lstStyle/>
+                    <a:p>
+                      <a:pPr algn="ctr"/>
+                      <a:r>
+                        <a:rPr sz="1100" b="0">
+                          <a:solidFill>
+                            <a:srgbClr val="3A3A4A"/>
+                          </a:solidFill>
+                          <a:latin typeface="Calibri"/>
+                        </a:rPr>
+                        <a:t>37</a:t>
+                      </a:r>
+                    </a:p>
+                  </a:txBody>
+                  <a:tcPr anchor="ctr" marL="73152" marR="73152" marT="27432" marB="27432">
+                    <a:solidFill>
+                      <a:srgbClr val="F5F0FC"/>
+                    </a:solidFill>
+                  </a:tcPr>
+                </a:tc>
+                <a:tc>
+                  <a:txBody>
+                    <a:bodyPr/>
+                    <a:lstStyle/>
+                    <a:p>
+                      <a:pPr algn="ctr"/>
+                      <a:r>
+                        <a:rPr sz="1100" b="0">
+                          <a:solidFill>
+                            <a:srgbClr val="3A3A4A"/>
+                          </a:solidFill>
+                          <a:latin typeface="Calibri"/>
+                        </a:rPr>
+                        <a:t>1.2%</a:t>
+                      </a:r>
+                    </a:p>
+                  </a:txBody>
+                  <a:tcPr anchor="ctr" marL="73152" marR="73152" marT="27432" marB="27432">
+                    <a:solidFill>
+                      <a:srgbClr val="F5F0FC"/>
+                    </a:solidFill>
+                  </a:tcPr>
+                </a:tc>
+                <a:tc>
+                  <a:txBody>
+                    <a:bodyPr/>
+                    <a:lstStyle/>
+                    <a:p>
+                      <a:pPr algn="ctr"/>
+                      <a:r>
+                        <a:rPr sz="1100" b="0">
+                          <a:solidFill>
+                            <a:srgbClr val="3A3A4A"/>
+                          </a:solidFill>
+                          <a:latin typeface="Calibri"/>
+                        </a:rPr>
+                        <a:t>$1,385,175</a:t>
                       </a:r>
                     </a:p>
                   </a:txBody>
@@ -11168,7 +11168,7 @@
                 </a:solidFill>
                 <a:latin typeface="Calibri"/>
               </a:rPr>
-              <a:t>Source: Metabase Card 6472 + HubSpot  ·  May 30, 2026</a:t>
+              <a:t>Source: Metabase Card 6472 + HubSpot  ·  May 31, 2026</a:t>
             </a:r>
           </a:p>
         </p:txBody>
@@ -11908,7 +11908,7 @@
                           </a:solidFill>
                           <a:latin typeface="Calibri"/>
                         </a:rPr>
-                        <a:t>James Reid</a:t>
+                        <a:t>—</a:t>
                       </a:r>
                     </a:p>
                   </a:txBody>
@@ -12909,7 +12909,7 @@
                           </a:solidFill>
                           <a:latin typeface="Calibri"/>
                         </a:rPr>
-                        <a:t>140</a:t>
+                        <a:t>141</a:t>
                       </a:r>
                     </a:p>
                   </a:txBody>
@@ -12932,7 +12932,7 @@
                           </a:solidFill>
                           <a:latin typeface="Calibri"/>
                         </a:rPr>
-                        <a:t>80</a:t>
+                        <a:t>81</a:t>
                       </a:r>
                     </a:p>
                   </a:txBody>
@@ -15243,7 +15243,7 @@
                 </a:solidFill>
                 <a:latin typeface="Calibri"/>
               </a:rPr>
-              <a:t>Source: Metabase Card 6472  ·  May 30, 2026</a:t>
+              <a:t>Source: Metabase Card 6472  ·  May 31, 2026</a:t>
             </a:r>
           </a:p>
         </p:txBody>
@@ -15866,7 +15866,7 @@
                           </a:solidFill>
                           <a:latin typeface="Calibri"/>
                         </a:rPr>
-                        <a:t>1,309</a:t>
+                        <a:t>1,310</a:t>
                       </a:r>
                     </a:p>
                   </a:txBody>
@@ -17496,7 +17496,7 @@
                           </a:solidFill>
                           <a:latin typeface="Calibri"/>
                         </a:rPr>
-                        <a:t>76</a:t>
+                        <a:t>77</a:t>
                       </a:r>
                     </a:p>
                   </a:txBody>
@@ -18637,7 +18637,7 @@
                           </a:solidFill>
                           <a:latin typeface="Calibri"/>
                         </a:rPr>
-                        <a:t>73</a:t>
+                        <a:t>74</a:t>
                       </a:r>
                     </a:p>
                   </a:txBody>
@@ -19609,7 +19609,7 @@
                 </a:solidFill>
                 <a:latin typeface="Calibri"/>
               </a:rPr>
-              <a:t>Source: Metabase Card 6472  ·  May 30, 2026</a:t>
+              <a:t>Source: Metabase Card 6472  ·  May 31, 2026</a:t>
             </a:r>
           </a:p>
         </p:txBody>
@@ -22207,7 +22207,7 @@
                 </a:solidFill>
                 <a:latin typeface="Calibri"/>
               </a:rPr>
-              <a:t>Source: Metabase Card 6472  ·  May 30, 2026</a:t>
+              <a:t>Source: Metabase Card 6472  ·  May 31, 2026</a:t>
             </a:r>
           </a:p>
         </p:txBody>
@@ -23623,7 +23623,7 @@
                           </a:solidFill>
                           <a:latin typeface="Calibri"/>
                         </a:rPr>
-                        <a:t>James Reid</a:t>
+                        <a:t>—</a:t>
                       </a:r>
                     </a:p>
                   </a:txBody>
@@ -25157,7 +25157,7 @@
                 </a:solidFill>
                 <a:latin typeface="Calibri"/>
               </a:rPr>
-              <a:t>Source: Metabase Card 6472  ·  May 30, 2026</a:t>
+              <a:t>Source: Metabase Card 6472  ·  May 31, 2026</a:t>
             </a:r>
           </a:p>
         </p:txBody>

</xml_diff>